<commit_message>
bchwtz published a site update
</commit_message>
<xml_diff>
--- a/data/bchwtz-postermaster.pptx
+++ b/data/bchwtz-postermaster.pptx
@@ -5,15 +5,16 @@
     <p:sldMasterId id="2147483660" r:id="rId1"/>
   </p:sldMasterIdLst>
   <p:notesMasterIdLst>
-    <p:notesMasterId r:id="rId5"/>
+    <p:notesMasterId r:id="rId6"/>
   </p:notesMasterIdLst>
   <p:handoutMasterIdLst>
-    <p:handoutMasterId r:id="rId6"/>
+    <p:handoutMasterId r:id="rId7"/>
   </p:handoutMasterIdLst>
   <p:sldIdLst>
     <p:sldId id="256" r:id="rId2"/>
-    <p:sldId id="258" r:id="rId3"/>
-    <p:sldId id="257" r:id="rId4"/>
+    <p:sldId id="259" r:id="rId3"/>
+    <p:sldId id="258" r:id="rId4"/>
+    <p:sldId id="257" r:id="rId5"/>
   </p:sldIdLst>
   <p:sldSz cx="21383625" cy="30275213"/>
   <p:notesSz cx="6858000" cy="9144000"/>
@@ -118,6 +119,7 @@
         <p14:section name="Academic Poster" id="{AAD427FA-8854-094A-9F3E-F9BC35E46DFB}">
           <p14:sldIdLst>
             <p14:sldId id="256"/>
+            <p14:sldId id="259"/>
           </p14:sldIdLst>
         </p14:section>
         <p14:section name="Academic Poster (Blind)" id="{632CA5EF-AF15-A340-9C5E-F4537964EA33}">
@@ -180,6 +182,9 @@
           </p15:clr>
         </p15:guide>
       </p15:sldGuideLst>
+    </p:ext>
+    <p:ext uri="{2D200454-40CA-4A62-9FC3-DE9A4176ACB9}">
+      <p15:notesGuideLst xmlns:p15="http://schemas.microsoft.com/office/powerpoint/2012/main"/>
     </p:ext>
   </p:extLst>
 </p:presentation>
@@ -279,7 +284,7 @@
           <a:p>
             <a:fld id="{48E8CEED-9D39-5F45-A794-537539148F8F}" type="datetimeFigureOut">
               <a:rPr lang="de-DE" smtClean="0"/>
-              <a:t>18.02.25</a:t>
+              <a:t>27.07.26</a:t>
             </a:fld>
             <a:endParaRPr lang="de-DE"/>
           </a:p>
@@ -472,7 +477,7 @@
           <a:p>
             <a:fld id="{096632BD-23DD-8147-A026-1F04B97B7E75}" type="datetimeFigureOut">
               <a:rPr lang="de-DE" smtClean="0"/>
-              <a:t>18.02.25</a:t>
+              <a:t>27.07.26</a:t>
             </a:fld>
             <a:endParaRPr lang="de-DE"/>
           </a:p>
@@ -831,6 +836,114 @@
         <p:cNvPr id="1" name="">
           <a:extLst>
             <a:ext uri="{FF2B5EF4-FFF2-40B4-BE49-F238E27FC236}">
+              <a16:creationId xmlns:a16="http://schemas.microsoft.com/office/drawing/2014/main" id="{E879CFD4-5D2D-C244-20A2-39270D6FB671}"/>
+            </a:ext>
+          </a:extLst>
+        </p:cNvPr>
+        <p:cNvGrpSpPr/>
+        <p:nvPr/>
+      </p:nvGrpSpPr>
+      <p:grpSpPr>
+        <a:xfrm>
+          <a:off x="0" y="0"/>
+          <a:ext cx="0" cy="0"/>
+          <a:chOff x="0" y="0"/>
+          <a:chExt cx="0" cy="0"/>
+        </a:xfrm>
+      </p:grpSpPr>
+      <p:sp>
+        <p:nvSpPr>
+          <p:cNvPr id="2" name="Folienbildplatzhalter 1">
+            <a:extLst>
+              <a:ext uri="{FF2B5EF4-FFF2-40B4-BE49-F238E27FC236}">
+                <a16:creationId xmlns:a16="http://schemas.microsoft.com/office/drawing/2014/main" id="{1C9664FF-A048-9F18-6CC2-68B1EC0EF8B2}"/>
+              </a:ext>
+            </a:extLst>
+          </p:cNvPr>
+          <p:cNvSpPr>
+            <a:spLocks noGrp="1" noRot="1" noChangeAspect="1"/>
+          </p:cNvSpPr>
+          <p:nvPr>
+            <p:ph type="sldImg"/>
+          </p:nvPr>
+        </p:nvSpPr>
+        <p:spPr/>
+      </p:sp>
+      <p:sp>
+        <p:nvSpPr>
+          <p:cNvPr id="3" name="Notizenplatzhalter 2">
+            <a:extLst>
+              <a:ext uri="{FF2B5EF4-FFF2-40B4-BE49-F238E27FC236}">
+                <a16:creationId xmlns:a16="http://schemas.microsoft.com/office/drawing/2014/main" id="{4140DE2A-8C3C-F8A6-56AC-72B94AFCCA22}"/>
+              </a:ext>
+            </a:extLst>
+          </p:cNvPr>
+          <p:cNvSpPr>
+            <a:spLocks noGrp="1"/>
+          </p:cNvSpPr>
+          <p:nvPr>
+            <p:ph type="body" idx="1"/>
+          </p:nvPr>
+        </p:nvSpPr>
+        <p:spPr/>
+        <p:txBody>
+          <a:bodyPr/>
+          <a:lstStyle/>
+          <a:p>
+            <a:endParaRPr lang="de-DE" dirty="0"/>
+          </a:p>
+        </p:txBody>
+      </p:sp>
+      <p:sp>
+        <p:nvSpPr>
+          <p:cNvPr id="4" name="Foliennummernplatzhalter 3">
+            <a:extLst>
+              <a:ext uri="{FF2B5EF4-FFF2-40B4-BE49-F238E27FC236}">
+                <a16:creationId xmlns:a16="http://schemas.microsoft.com/office/drawing/2014/main" id="{F37F1B39-277E-BBF5-2078-5F5F75969940}"/>
+              </a:ext>
+            </a:extLst>
+          </p:cNvPr>
+          <p:cNvSpPr>
+            <a:spLocks noGrp="1"/>
+          </p:cNvSpPr>
+          <p:nvPr>
+            <p:ph type="sldNum" sz="quarter" idx="5"/>
+          </p:nvPr>
+        </p:nvSpPr>
+        <p:spPr/>
+        <p:txBody>
+          <a:bodyPr/>
+          <a:lstStyle/>
+          <a:p>
+            <a:fld id="{B9AF2651-5371-BC49-953C-50D99E042BAC}" type="slidenum">
+              <a:rPr lang="de-DE" smtClean="0"/>
+              <a:t>2</a:t>
+            </a:fld>
+            <a:endParaRPr lang="de-DE"/>
+          </a:p>
+        </p:txBody>
+      </p:sp>
+    </p:spTree>
+    <p:extLst>
+      <p:ext uri="{BB962C8B-B14F-4D97-AF65-F5344CB8AC3E}">
+        <p14:creationId xmlns:p14="http://schemas.microsoft.com/office/powerpoint/2010/main" val="613745386"/>
+      </p:ext>
+    </p:extLst>
+  </p:cSld>
+  <p:clrMapOvr>
+    <a:masterClrMapping/>
+  </p:clrMapOvr>
+</p:notes>
+</file>
+
+<file path=ppt/notesSlides/notesSlide3.xml><?xml version="1.0" encoding="utf-8"?>
+<p:notes xmlns:a="http://schemas.openxmlformats.org/drawingml/2006/main" xmlns:r="http://schemas.openxmlformats.org/officeDocument/2006/relationships" xmlns:p="http://schemas.openxmlformats.org/presentationml/2006/main">
+  <p:cSld>
+    <p:spTree>
+      <p:nvGrpSpPr>
+        <p:cNvPr id="1" name="">
+          <a:extLst>
+            <a:ext uri="{FF2B5EF4-FFF2-40B4-BE49-F238E27FC236}">
               <a16:creationId xmlns:a16="http://schemas.microsoft.com/office/drawing/2014/main" id="{F8EDC4F0-D4B5-EC12-3D85-B43FBF282AB1}"/>
             </a:ext>
           </a:extLst>
@@ -912,7 +1025,7 @@
           <a:p>
             <a:fld id="{B9AF2651-5371-BC49-953C-50D99E042BAC}" type="slidenum">
               <a:rPr lang="de-DE" smtClean="0"/>
-              <a:t>2</a:t>
+              <a:t>3</a:t>
             </a:fld>
             <a:endParaRPr lang="de-DE"/>
           </a:p>
@@ -981,14 +1094,14 @@
           <a:effectLst/>
           <a:extLst>
             <a:ext uri="{909E8E84-426E-40dd-AFC4-6F175D3DCCD1}">
-              <a14:hiddenFill xmlns="" xmlns:a14="http://schemas.microsoft.com/office/drawing/2010/main">
+              <a14:hiddenFill xmlns:a14="http://schemas.microsoft.com/office/drawing/2010/main" xmlns="">
                 <a:solidFill>
                   <a:schemeClr val="accent2"/>
                 </a:solidFill>
               </a14:hiddenFill>
             </a:ext>
             <a:ext uri="{AF507438-7753-43e0-B8FC-AC1667EBCBE1}">
-              <a14:hiddenEffects xmlns="" xmlns:a14="http://schemas.microsoft.com/office/drawing/2010/main">
+              <a14:hiddenEffects xmlns:a14="http://schemas.microsoft.com/office/drawing/2010/main" xmlns="">
                 <a:effectLst>
                   <a:outerShdw blurRad="63500" dist="35921" dir="2700000" algn="ctr" rotWithShape="0">
                     <a:schemeClr val="bg2"/>
@@ -1422,14 +1535,14 @@
           <a:effectLst/>
           <a:extLst>
             <a:ext uri="{909E8E84-426E-40dd-AFC4-6F175D3DCCD1}">
-              <a14:hiddenFill xmlns="" xmlns:a14="http://schemas.microsoft.com/office/drawing/2010/main">
+              <a14:hiddenFill xmlns:a14="http://schemas.microsoft.com/office/drawing/2010/main" xmlns="">
                 <a:solidFill>
                   <a:schemeClr val="accent2"/>
                 </a:solidFill>
               </a14:hiddenFill>
             </a:ext>
             <a:ext uri="{AF507438-7753-43e0-B8FC-AC1667EBCBE1}">
-              <a14:hiddenEffects xmlns="" xmlns:a14="http://schemas.microsoft.com/office/drawing/2010/main">
+              <a14:hiddenEffects xmlns:a14="http://schemas.microsoft.com/office/drawing/2010/main" xmlns="">
                 <a:effectLst>
                   <a:outerShdw blurRad="63500" dist="35921" dir="2700000" algn="ctr" rotWithShape="0">
                     <a:schemeClr val="bg2"/>
@@ -3390,8 +3503,8 @@
           </a:p>
         </p:txBody>
       </p:sp>
-      <mc:AlternateContent xmlns:mc="http://schemas.openxmlformats.org/markup-compatibility/2006">
-        <mc:Choice xmlns:a14="http://schemas.microsoft.com/office/drawing/2010/main" Requires="a14">
+      <mc:AlternateContent xmlns:mc="http://schemas.openxmlformats.org/markup-compatibility/2006" xmlns:a14="http://schemas.microsoft.com/office/drawing/2010/main">
+        <mc:Choice Requires="a14">
           <p:sp>
             <p:nvSpPr>
               <p:cNvPr id="7" name="Text Placeholder 2">
@@ -5193,7 +5306,7 @@
             </p:txBody>
           </p:sp>
         </mc:Choice>
-        <mc:Fallback>
+        <mc:Fallback xmlns="">
           <p:sp>
             <p:nvSpPr>
               <p:cNvPr id="7" name="Text Placeholder 2">
@@ -8387,10 +8500,10 @@
           <p:nvPr/>
         </p:nvPicPr>
         <p:blipFill rotWithShape="1">
-          <a:blip r:embed="rId4">
+          <a:blip>
             <a:extLst>
               <a:ext uri="{96DAC541-7B7A-43D3-8B79-37D633B846F1}">
-                <asvg:svgBlip xmlns:asvg="http://schemas.microsoft.com/office/drawing/2016/SVG/main" r:embed="rId5"/>
+                <asvg:svgBlip xmlns:asvg="http://schemas.microsoft.com/office/drawing/2016/SVG/main" r:embed="rId4"/>
               </a:ext>
             </a:extLst>
           </a:blip>
@@ -12831,7 +12944,7 @@
           <p:nvPr/>
         </p:nvPicPr>
         <p:blipFill>
-          <a:blip r:embed="rId6">
+          <a:blip r:embed="rId5">
             <a:extLst>
               <a:ext uri="{28A0092B-C50C-407E-A947-70E740481C1C}">
                 <a14:useLocalDpi xmlns:a14="http://schemas.microsoft.com/office/drawing/2010/main" val="0"/>
@@ -14918,16 +15031,288 @@
                 <a:ea typeface="Helvetica Neue Medium" panose="02000503000000020004" pitchFamily="2" charset="0"/>
                 <a:cs typeface="Helvetica Neue Medium" panose="02000503000000020004" pitchFamily="2" charset="0"/>
               </a:rPr>
-              <a:t>Front A2 (420mm x 592mm)</a:t>
-            </a:r>
-            <a:endParaRPr lang="de-DE" sz="10000" dirty="0">
-              <a:latin typeface="Helvetica Neue Medium" panose="02000503000000020004" pitchFamily="2" charset="0"/>
-              <a:ea typeface="Helvetica Neue Medium" panose="02000503000000020004" pitchFamily="2" charset="0"/>
-              <a:cs typeface="Helvetica Neue Medium" panose="02000503000000020004" pitchFamily="2" charset="0"/>
-            </a:endParaRPr>
+              <a:t>Front A1 (594mm x 841mm)</a:t>
+            </a:r>
           </a:p>
         </p:txBody>
       </p:sp>
+      <p:grpSp>
+        <p:nvGrpSpPr>
+          <p:cNvPr id="13" name="Gruppieren 12">
+            <a:extLst>
+              <a:ext uri="{FF2B5EF4-FFF2-40B4-BE49-F238E27FC236}">
+                <a16:creationId xmlns:a16="http://schemas.microsoft.com/office/drawing/2014/main" id="{EC1E32B4-1246-A3F5-1720-59343BC5719D}"/>
+              </a:ext>
+            </a:extLst>
+          </p:cNvPr>
+          <p:cNvGrpSpPr/>
+          <p:nvPr/>
+        </p:nvGrpSpPr>
+        <p:grpSpPr>
+          <a:xfrm>
+            <a:off x="22963250" y="-1575609"/>
+            <a:ext cx="8580093" cy="16044118"/>
+            <a:chOff x="23914791" y="-1323439"/>
+            <a:chExt cx="8580093" cy="16044118"/>
+          </a:xfrm>
+        </p:grpSpPr>
+        <p:sp>
+          <p:nvSpPr>
+            <p:cNvPr id="4" name="Rechteck 3">
+              <a:extLst>
+                <a:ext uri="{FF2B5EF4-FFF2-40B4-BE49-F238E27FC236}">
+                  <a16:creationId xmlns:a16="http://schemas.microsoft.com/office/drawing/2014/main" id="{B18C043E-A359-7260-4A21-DD3726E72BE1}"/>
+                </a:ext>
+              </a:extLst>
+            </p:cNvPr>
+            <p:cNvSpPr/>
+            <p:nvPr/>
+          </p:nvSpPr>
+          <p:spPr>
+            <a:xfrm>
+              <a:off x="23941284" y="6050531"/>
+              <a:ext cx="8553600" cy="6048000"/>
+            </a:xfrm>
+            <a:prstGeom prst="rect">
+              <a:avLst/>
+            </a:prstGeom>
+            <a:solidFill>
+              <a:srgbClr val="00509B"/>
+            </a:solidFill>
+            <a:ln w="63500"/>
+          </p:spPr>
+          <p:style>
+            <a:lnRef idx="2">
+              <a:schemeClr val="accent1">
+                <a:shade val="15000"/>
+              </a:schemeClr>
+            </a:lnRef>
+            <a:fillRef idx="1">
+              <a:schemeClr val="accent1"/>
+            </a:fillRef>
+            <a:effectRef idx="0">
+              <a:schemeClr val="accent1"/>
+            </a:effectRef>
+            <a:fontRef idx="minor">
+              <a:schemeClr val="lt1"/>
+            </a:fontRef>
+          </p:style>
+          <p:txBody>
+            <a:bodyPr rtlCol="0" anchor="ctr"/>
+            <a:lstStyle/>
+            <a:p>
+              <a:pPr algn="ctr"/>
+              <a:r>
+                <a:rPr lang="de-DE" sz="8000" b="1" dirty="0">
+                  <a:latin typeface="Arial" panose="020B0604020202020204" pitchFamily="34" charset="0"/>
+                  <a:cs typeface="Arial" panose="020B0604020202020204" pitchFamily="34" charset="0"/>
+                </a:rPr>
+                <a:t>A2</a:t>
+              </a:r>
+            </a:p>
+          </p:txBody>
+        </p:sp>
+        <p:sp>
+          <p:nvSpPr>
+            <p:cNvPr id="5" name="Rechteck 4">
+              <a:extLst>
+                <a:ext uri="{FF2B5EF4-FFF2-40B4-BE49-F238E27FC236}">
+                  <a16:creationId xmlns:a16="http://schemas.microsoft.com/office/drawing/2014/main" id="{112AEC6E-80B4-0FB5-67CD-A33D11439281}"/>
+                </a:ext>
+              </a:extLst>
+            </p:cNvPr>
+            <p:cNvSpPr/>
+            <p:nvPr/>
+          </p:nvSpPr>
+          <p:spPr>
+            <a:xfrm>
+              <a:off x="28218084" y="0"/>
+              <a:ext cx="4276800" cy="6048000"/>
+            </a:xfrm>
+            <a:prstGeom prst="rect">
+              <a:avLst/>
+            </a:prstGeom>
+            <a:solidFill>
+              <a:srgbClr val="00509B"/>
+            </a:solidFill>
+            <a:ln w="63500"/>
+          </p:spPr>
+          <p:style>
+            <a:lnRef idx="2">
+              <a:schemeClr val="accent1">
+                <a:shade val="15000"/>
+              </a:schemeClr>
+            </a:lnRef>
+            <a:fillRef idx="1">
+              <a:schemeClr val="accent1"/>
+            </a:fillRef>
+            <a:effectRef idx="0">
+              <a:schemeClr val="accent1"/>
+            </a:effectRef>
+            <a:fontRef idx="minor">
+              <a:schemeClr val="lt1"/>
+            </a:fontRef>
+          </p:style>
+          <p:txBody>
+            <a:bodyPr rtlCol="0" anchor="ctr"/>
+            <a:lstStyle/>
+            <a:p>
+              <a:pPr algn="ctr"/>
+              <a:r>
+                <a:rPr lang="de-DE" sz="8000" b="1" dirty="0">
+                  <a:latin typeface="Arial" panose="020B0604020202020204" pitchFamily="34" charset="0"/>
+                  <a:cs typeface="Arial" panose="020B0604020202020204" pitchFamily="34" charset="0"/>
+                </a:rPr>
+                <a:t>A3</a:t>
+              </a:r>
+            </a:p>
+          </p:txBody>
+        </p:sp>
+        <p:sp>
+          <p:nvSpPr>
+            <p:cNvPr id="8" name="Rechteck 7">
+              <a:extLst>
+                <a:ext uri="{FF2B5EF4-FFF2-40B4-BE49-F238E27FC236}">
+                  <a16:creationId xmlns:a16="http://schemas.microsoft.com/office/drawing/2014/main" id="{473B915A-B7C6-893D-7C58-9C3063757E29}"/>
+                </a:ext>
+              </a:extLst>
+            </p:cNvPr>
+            <p:cNvSpPr/>
+            <p:nvPr/>
+          </p:nvSpPr>
+          <p:spPr>
+            <a:xfrm>
+              <a:off x="23941284" y="0"/>
+              <a:ext cx="4276800" cy="6048000"/>
+            </a:xfrm>
+            <a:prstGeom prst="rect">
+              <a:avLst/>
+            </a:prstGeom>
+            <a:solidFill>
+              <a:srgbClr val="00509B"/>
+            </a:solidFill>
+            <a:ln w="63500"/>
+          </p:spPr>
+          <p:style>
+            <a:lnRef idx="2">
+              <a:schemeClr val="accent1">
+                <a:shade val="15000"/>
+              </a:schemeClr>
+            </a:lnRef>
+            <a:fillRef idx="1">
+              <a:schemeClr val="accent1"/>
+            </a:fillRef>
+            <a:effectRef idx="0">
+              <a:schemeClr val="accent1"/>
+            </a:effectRef>
+            <a:fontRef idx="minor">
+              <a:schemeClr val="lt1"/>
+            </a:fontRef>
+          </p:style>
+          <p:txBody>
+            <a:bodyPr rtlCol="0" anchor="ctr"/>
+            <a:lstStyle/>
+            <a:p>
+              <a:pPr algn="ctr"/>
+              <a:r>
+                <a:rPr lang="de-DE" sz="8000" b="1" dirty="0">
+                  <a:latin typeface="Arial" panose="020B0604020202020204" pitchFamily="34" charset="0"/>
+                  <a:cs typeface="Arial" panose="020B0604020202020204" pitchFamily="34" charset="0"/>
+                </a:rPr>
+                <a:t>A3</a:t>
+              </a:r>
+            </a:p>
+          </p:txBody>
+        </p:sp>
+        <p:sp>
+          <p:nvSpPr>
+            <p:cNvPr id="9" name="Textfeld 8">
+              <a:extLst>
+                <a:ext uri="{FF2B5EF4-FFF2-40B4-BE49-F238E27FC236}">
+                  <a16:creationId xmlns:a16="http://schemas.microsoft.com/office/drawing/2014/main" id="{71CFB17B-F31A-17D5-1423-5D400AB59372}"/>
+                </a:ext>
+              </a:extLst>
+            </p:cNvPr>
+            <p:cNvSpPr txBox="1"/>
+            <p:nvPr/>
+          </p:nvSpPr>
+          <p:spPr>
+            <a:xfrm>
+              <a:off x="23914792" y="-1323439"/>
+              <a:ext cx="6234399" cy="1323439"/>
+            </a:xfrm>
+            <a:prstGeom prst="rect">
+              <a:avLst/>
+            </a:prstGeom>
+            <a:noFill/>
+          </p:spPr>
+          <p:txBody>
+            <a:bodyPr wrap="none" rtlCol="0">
+              <a:spAutoFit/>
+            </a:bodyPr>
+            <a:lstStyle/>
+            <a:p>
+              <a:r>
+                <a:rPr lang="de-DE" sz="8000" b="1" dirty="0">
+                  <a:latin typeface="Arial" panose="020B0604020202020204" pitchFamily="34" charset="0"/>
+                  <a:cs typeface="Arial" panose="020B0604020202020204" pitchFamily="34" charset="0"/>
+                </a:rPr>
+                <a:t>A1 </a:t>
+              </a:r>
+              <a:r>
+                <a:rPr lang="de-DE" sz="4000" b="1" dirty="0">
+                  <a:latin typeface="Arial" panose="020B0604020202020204" pitchFamily="34" charset="0"/>
+                  <a:cs typeface="Arial" panose="020B0604020202020204" pitchFamily="34" charset="0"/>
+                </a:rPr>
+                <a:t>(594mm x 841mm)</a:t>
+              </a:r>
+            </a:p>
+          </p:txBody>
+        </p:sp>
+        <p:sp>
+          <p:nvSpPr>
+            <p:cNvPr id="12" name="Textfeld 11">
+              <a:extLst>
+                <a:ext uri="{FF2B5EF4-FFF2-40B4-BE49-F238E27FC236}">
+                  <a16:creationId xmlns:a16="http://schemas.microsoft.com/office/drawing/2014/main" id="{AC1E952B-89E0-6D83-F6DA-C9BADA8EF03E}"/>
+                </a:ext>
+              </a:extLst>
+            </p:cNvPr>
+            <p:cNvSpPr txBox="1"/>
+            <p:nvPr/>
+          </p:nvSpPr>
+          <p:spPr>
+            <a:xfrm>
+              <a:off x="23914791" y="12444344"/>
+              <a:ext cx="8553600" cy="2276335"/>
+            </a:xfrm>
+            <a:prstGeom prst="rect">
+              <a:avLst/>
+            </a:prstGeom>
+            <a:noFill/>
+          </p:spPr>
+          <p:txBody>
+            <a:bodyPr wrap="square" rtlCol="0">
+              <a:noAutofit/>
+            </a:bodyPr>
+            <a:lstStyle/>
+            <a:p>
+              <a:pPr algn="just">
+                <a:lnSpc>
+                  <a:spcPct val="90000"/>
+                </a:lnSpc>
+              </a:pPr>
+              <a:r>
+                <a:rPr lang="en-GB" sz="3600" noProof="1">
+                  <a:latin typeface="Arial" panose="020B0604020202020204" pitchFamily="34" charset="0"/>
+                  <a:cs typeface="Arial" panose="020B0604020202020204" pitchFamily="34" charset="0"/>
+                </a:rPr>
+                <a:t>This Poster is to be printed in A1, which can be achieved by combining four A3 or eight A4 sheets. The printers at Fachhochschule Südwestfalen are able to print A3 sheets.</a:t>
+              </a:r>
+            </a:p>
+          </p:txBody>
+        </p:sp>
+      </p:grpSp>
     </p:spTree>
     <p:extLst>
       <p:ext uri="{BB962C8B-B14F-4D97-AF65-F5344CB8AC3E}">
@@ -14942,6 +15327,1846 @@
 </file>
 
 <file path=ppt/slides/slide2.xml><?xml version="1.0" encoding="utf-8"?>
+<p:sld xmlns:a="http://schemas.openxmlformats.org/drawingml/2006/main" xmlns:r="http://schemas.openxmlformats.org/officeDocument/2006/relationships" xmlns:p="http://schemas.openxmlformats.org/presentationml/2006/main">
+  <p:cSld>
+    <p:spTree>
+      <p:nvGrpSpPr>
+        <p:cNvPr id="1" name="">
+          <a:extLst>
+            <a:ext uri="{FF2B5EF4-FFF2-40B4-BE49-F238E27FC236}">
+              <a16:creationId xmlns:a16="http://schemas.microsoft.com/office/drawing/2014/main" id="{AD61ADE5-C4CC-9764-9A74-720296585012}"/>
+            </a:ext>
+          </a:extLst>
+        </p:cNvPr>
+        <p:cNvGrpSpPr/>
+        <p:nvPr/>
+      </p:nvGrpSpPr>
+      <p:grpSpPr>
+        <a:xfrm>
+          <a:off x="0" y="0"/>
+          <a:ext cx="0" cy="0"/>
+          <a:chOff x="0" y="0"/>
+          <a:chExt cx="0" cy="0"/>
+        </a:xfrm>
+      </p:grpSpPr>
+      <p:sp>
+        <p:nvSpPr>
+          <p:cNvPr id="6" name="Textfeld 5">
+            <a:extLst>
+              <a:ext uri="{FF2B5EF4-FFF2-40B4-BE49-F238E27FC236}">
+                <a16:creationId xmlns:a16="http://schemas.microsoft.com/office/drawing/2014/main" id="{E6DAE5A5-46F6-38F7-7F00-BB53DD3E7DE9}"/>
+              </a:ext>
+            </a:extLst>
+          </p:cNvPr>
+          <p:cNvSpPr txBox="1"/>
+          <p:nvPr/>
+        </p:nvSpPr>
+        <p:spPr>
+          <a:xfrm>
+            <a:off x="0" y="-1631216"/>
+            <a:ext cx="16339729" cy="1631216"/>
+          </a:xfrm>
+          <a:prstGeom prst="rect">
+            <a:avLst/>
+          </a:prstGeom>
+          <a:noFill/>
+        </p:spPr>
+        <p:txBody>
+          <a:bodyPr wrap="none" rtlCol="0">
+            <a:spAutoFit/>
+          </a:bodyPr>
+          <a:lstStyle/>
+          <a:p>
+            <a:r>
+              <a:rPr lang="de-DE" sz="10000" dirty="0">
+                <a:latin typeface="Helvetica Neue Medium" panose="02000503000000020004" pitchFamily="2" charset="0"/>
+                <a:ea typeface="Helvetica Neue Medium" panose="02000503000000020004" pitchFamily="2" charset="0"/>
+                <a:cs typeface="Helvetica Neue Medium" panose="02000503000000020004" pitchFamily="2" charset="0"/>
+              </a:rPr>
+              <a:t>Back A1 (594mm x 841mm)</a:t>
+            </a:r>
+          </a:p>
+        </p:txBody>
+      </p:sp>
+      <p:sp>
+        <p:nvSpPr>
+          <p:cNvPr id="4" name="Text Placeholder 2">
+            <a:extLst>
+              <a:ext uri="{FF2B5EF4-FFF2-40B4-BE49-F238E27FC236}">
+                <a16:creationId xmlns:a16="http://schemas.microsoft.com/office/drawing/2014/main" id="{027DE312-C761-C6C5-5114-DF9D53E74497}"/>
+              </a:ext>
+            </a:extLst>
+          </p:cNvPr>
+          <p:cNvSpPr txBox="1">
+            <a:spLocks noChangeAspect="1"/>
+          </p:cNvSpPr>
+          <p:nvPr/>
+        </p:nvSpPr>
+        <p:spPr>
+          <a:xfrm>
+            <a:off x="1330325" y="1816100"/>
+            <a:ext cx="9001261" cy="927666"/>
+          </a:xfrm>
+          <a:prstGeom prst="rect">
+            <a:avLst/>
+          </a:prstGeom>
+          <a:solidFill>
+            <a:srgbClr val="00509B"/>
+          </a:solidFill>
+        </p:spPr>
+        <p:txBody>
+          <a:bodyPr vert="horz" lIns="360000" tIns="46800" rIns="108000" bIns="45720" numCol="1" rtlCol="0" anchor="ctr">
+            <a:normAutofit/>
+          </a:bodyPr>
+          <a:lstStyle>
+            <a:lvl1pPr marL="0" indent="0" algn="ctr" defTabSz="2138324" rtl="0" eaLnBrk="1" latinLnBrk="0" hangingPunct="1">
+              <a:lnSpc>
+                <a:spcPct val="90000"/>
+              </a:lnSpc>
+              <a:spcBef>
+                <a:spcPts val="2339"/>
+              </a:spcBef>
+              <a:buFont typeface="Arial" panose="020B0604020202020204" pitchFamily="34" charset="0"/>
+              <a:buNone/>
+              <a:defRPr sz="5612" kern="1200">
+                <a:solidFill>
+                  <a:schemeClr val="tx1"/>
+                </a:solidFill>
+                <a:latin typeface="Arial" panose="020B0604020202020204" pitchFamily="34" charset="0"/>
+                <a:ea typeface="+mn-ea"/>
+                <a:cs typeface="Arial" panose="020B0604020202020204" pitchFamily="34" charset="0"/>
+              </a:defRPr>
+            </a:lvl1pPr>
+            <a:lvl2pPr marL="1069162" indent="0" algn="ctr" defTabSz="2138324" rtl="0" eaLnBrk="1" latinLnBrk="0" hangingPunct="1">
+              <a:lnSpc>
+                <a:spcPct val="90000"/>
+              </a:lnSpc>
+              <a:spcBef>
+                <a:spcPts val="1169"/>
+              </a:spcBef>
+              <a:buFont typeface="Arial" panose="020B0604020202020204" pitchFamily="34" charset="0"/>
+              <a:buNone/>
+              <a:defRPr sz="4677" kern="1200">
+                <a:solidFill>
+                  <a:schemeClr val="tx1"/>
+                </a:solidFill>
+                <a:latin typeface="Arial" panose="020B0604020202020204" pitchFamily="34" charset="0"/>
+                <a:ea typeface="+mn-ea"/>
+                <a:cs typeface="Arial" panose="020B0604020202020204" pitchFamily="34" charset="0"/>
+              </a:defRPr>
+            </a:lvl2pPr>
+            <a:lvl3pPr marL="2138324" indent="0" algn="ctr" defTabSz="2138324" rtl="0" eaLnBrk="1" latinLnBrk="0" hangingPunct="1">
+              <a:lnSpc>
+                <a:spcPct val="90000"/>
+              </a:lnSpc>
+              <a:spcBef>
+                <a:spcPts val="1169"/>
+              </a:spcBef>
+              <a:buFont typeface="Arial" panose="020B0604020202020204" pitchFamily="34" charset="0"/>
+              <a:buNone/>
+              <a:defRPr sz="4209" kern="1200">
+                <a:solidFill>
+                  <a:schemeClr val="tx1"/>
+                </a:solidFill>
+                <a:latin typeface="Arial" panose="020B0604020202020204" pitchFamily="34" charset="0"/>
+                <a:ea typeface="+mn-ea"/>
+                <a:cs typeface="Arial" panose="020B0604020202020204" pitchFamily="34" charset="0"/>
+              </a:defRPr>
+            </a:lvl3pPr>
+            <a:lvl4pPr marL="3207487" indent="0" algn="ctr" defTabSz="2138324" rtl="0" eaLnBrk="1" latinLnBrk="0" hangingPunct="1">
+              <a:lnSpc>
+                <a:spcPct val="90000"/>
+              </a:lnSpc>
+              <a:spcBef>
+                <a:spcPts val="1169"/>
+              </a:spcBef>
+              <a:buFont typeface="Arial" panose="020B0604020202020204" pitchFamily="34" charset="0"/>
+              <a:buNone/>
+              <a:defRPr sz="3742" kern="1200">
+                <a:solidFill>
+                  <a:schemeClr val="tx1"/>
+                </a:solidFill>
+                <a:latin typeface="Arial" panose="020B0604020202020204" pitchFamily="34" charset="0"/>
+                <a:ea typeface="+mn-ea"/>
+                <a:cs typeface="Arial" panose="020B0604020202020204" pitchFamily="34" charset="0"/>
+              </a:defRPr>
+            </a:lvl4pPr>
+            <a:lvl5pPr marL="4276649" indent="0" algn="ctr" defTabSz="2138324" rtl="0" eaLnBrk="1" latinLnBrk="0" hangingPunct="1">
+              <a:lnSpc>
+                <a:spcPct val="90000"/>
+              </a:lnSpc>
+              <a:spcBef>
+                <a:spcPts val="1169"/>
+              </a:spcBef>
+              <a:buFont typeface="Arial" panose="020B0604020202020204" pitchFamily="34" charset="0"/>
+              <a:buNone/>
+              <a:defRPr sz="3742" kern="1200">
+                <a:solidFill>
+                  <a:schemeClr val="tx1"/>
+                </a:solidFill>
+                <a:latin typeface="Arial" panose="020B0604020202020204" pitchFamily="34" charset="0"/>
+                <a:ea typeface="+mn-ea"/>
+                <a:cs typeface="Arial" panose="020B0604020202020204" pitchFamily="34" charset="0"/>
+              </a:defRPr>
+            </a:lvl5pPr>
+            <a:lvl6pPr marL="5345811" indent="0" algn="ctr" defTabSz="2138324" rtl="0" eaLnBrk="1" latinLnBrk="0" hangingPunct="1">
+              <a:lnSpc>
+                <a:spcPct val="90000"/>
+              </a:lnSpc>
+              <a:spcBef>
+                <a:spcPts val="1169"/>
+              </a:spcBef>
+              <a:buFont typeface="Arial" panose="020B0604020202020204" pitchFamily="34" charset="0"/>
+              <a:buNone/>
+              <a:defRPr sz="3742" kern="1200">
+                <a:solidFill>
+                  <a:schemeClr val="tx1"/>
+                </a:solidFill>
+                <a:latin typeface="+mn-lt"/>
+                <a:ea typeface="+mn-ea"/>
+                <a:cs typeface="+mn-cs"/>
+              </a:defRPr>
+            </a:lvl6pPr>
+            <a:lvl7pPr marL="6414973" indent="0" algn="ctr" defTabSz="2138324" rtl="0" eaLnBrk="1" latinLnBrk="0" hangingPunct="1">
+              <a:lnSpc>
+                <a:spcPct val="90000"/>
+              </a:lnSpc>
+              <a:spcBef>
+                <a:spcPts val="1169"/>
+              </a:spcBef>
+              <a:buFont typeface="Arial" panose="020B0604020202020204" pitchFamily="34" charset="0"/>
+              <a:buNone/>
+              <a:defRPr sz="3742" kern="1200">
+                <a:solidFill>
+                  <a:schemeClr val="tx1"/>
+                </a:solidFill>
+                <a:latin typeface="+mn-lt"/>
+                <a:ea typeface="+mn-ea"/>
+                <a:cs typeface="+mn-cs"/>
+              </a:defRPr>
+            </a:lvl7pPr>
+            <a:lvl8pPr marL="7484135" indent="0" algn="ctr" defTabSz="2138324" rtl="0" eaLnBrk="1" latinLnBrk="0" hangingPunct="1">
+              <a:lnSpc>
+                <a:spcPct val="90000"/>
+              </a:lnSpc>
+              <a:spcBef>
+                <a:spcPts val="1169"/>
+              </a:spcBef>
+              <a:buFont typeface="Arial" panose="020B0604020202020204" pitchFamily="34" charset="0"/>
+              <a:buNone/>
+              <a:defRPr sz="3742" kern="1200">
+                <a:solidFill>
+                  <a:schemeClr val="tx1"/>
+                </a:solidFill>
+                <a:latin typeface="+mn-lt"/>
+                <a:ea typeface="+mn-ea"/>
+                <a:cs typeface="+mn-cs"/>
+              </a:defRPr>
+            </a:lvl8pPr>
+            <a:lvl9pPr marL="8553298" indent="0" algn="ctr" defTabSz="2138324" rtl="0" eaLnBrk="1" latinLnBrk="0" hangingPunct="1">
+              <a:lnSpc>
+                <a:spcPct val="90000"/>
+              </a:lnSpc>
+              <a:spcBef>
+                <a:spcPts val="1169"/>
+              </a:spcBef>
+              <a:buFont typeface="Arial" panose="020B0604020202020204" pitchFamily="34" charset="0"/>
+              <a:buNone/>
+              <a:defRPr sz="3742" kern="1200">
+                <a:solidFill>
+                  <a:schemeClr val="tx1"/>
+                </a:solidFill>
+                <a:latin typeface="+mn-lt"/>
+                <a:ea typeface="+mn-ea"/>
+                <a:cs typeface="+mn-cs"/>
+              </a:defRPr>
+            </a:lvl9pPr>
+          </a:lstStyle>
+          <a:p>
+            <a:pPr algn="l"/>
+            <a:r>
+              <a:rPr lang="de-DE" sz="3200" b="1" dirty="0">
+                <a:solidFill>
+                  <a:schemeClr val="bg1"/>
+                </a:solidFill>
+              </a:rPr>
+              <a:t>Literaturverzeichnis</a:t>
+            </a:r>
+          </a:p>
+        </p:txBody>
+      </p:sp>
+      <p:sp>
+        <p:nvSpPr>
+          <p:cNvPr id="5" name="Text Placeholder 2">
+            <a:extLst>
+              <a:ext uri="{FF2B5EF4-FFF2-40B4-BE49-F238E27FC236}">
+                <a16:creationId xmlns:a16="http://schemas.microsoft.com/office/drawing/2014/main" id="{A8277BF3-5BF5-8197-E61B-180630557D8A}"/>
+              </a:ext>
+            </a:extLst>
+          </p:cNvPr>
+          <p:cNvSpPr txBox="1">
+            <a:spLocks/>
+          </p:cNvSpPr>
+          <p:nvPr/>
+        </p:nvSpPr>
+        <p:spPr>
+          <a:xfrm>
+            <a:off x="1340709" y="2935033"/>
+            <a:ext cx="9001260" cy="25524053"/>
+          </a:xfrm>
+          <a:prstGeom prst="rect">
+            <a:avLst/>
+          </a:prstGeom>
+          <a:solidFill>
+            <a:schemeClr val="bg1">
+              <a:lumMod val="95000"/>
+            </a:schemeClr>
+          </a:solidFill>
+        </p:spPr>
+        <p:txBody>
+          <a:bodyPr vert="horz" lIns="360000" tIns="360000" rIns="360000" bIns="360000" numCol="1" rtlCol="0">
+            <a:noAutofit/>
+          </a:bodyPr>
+          <a:lstStyle>
+            <a:lvl1pPr marL="0" indent="0" algn="ctr" defTabSz="2138324" rtl="0" eaLnBrk="1" latinLnBrk="0" hangingPunct="1">
+              <a:lnSpc>
+                <a:spcPct val="90000"/>
+              </a:lnSpc>
+              <a:spcBef>
+                <a:spcPts val="2339"/>
+              </a:spcBef>
+              <a:buFont typeface="Arial" panose="020B0604020202020204" pitchFamily="34" charset="0"/>
+              <a:buNone/>
+              <a:defRPr sz="5612" kern="1200">
+                <a:solidFill>
+                  <a:schemeClr val="tx1"/>
+                </a:solidFill>
+                <a:latin typeface="Arial" panose="020B0604020202020204" pitchFamily="34" charset="0"/>
+                <a:ea typeface="+mn-ea"/>
+                <a:cs typeface="Arial" panose="020B0604020202020204" pitchFamily="34" charset="0"/>
+              </a:defRPr>
+            </a:lvl1pPr>
+            <a:lvl2pPr marL="1069162" indent="0" algn="ctr" defTabSz="2138324" rtl="0" eaLnBrk="1" latinLnBrk="0" hangingPunct="1">
+              <a:lnSpc>
+                <a:spcPct val="90000"/>
+              </a:lnSpc>
+              <a:spcBef>
+                <a:spcPts val="1169"/>
+              </a:spcBef>
+              <a:buFont typeface="Arial" panose="020B0604020202020204" pitchFamily="34" charset="0"/>
+              <a:buNone/>
+              <a:defRPr sz="4677" kern="1200">
+                <a:solidFill>
+                  <a:schemeClr val="tx1"/>
+                </a:solidFill>
+                <a:latin typeface="Arial" panose="020B0604020202020204" pitchFamily="34" charset="0"/>
+                <a:ea typeface="+mn-ea"/>
+                <a:cs typeface="Arial" panose="020B0604020202020204" pitchFamily="34" charset="0"/>
+              </a:defRPr>
+            </a:lvl2pPr>
+            <a:lvl3pPr marL="2138324" indent="0" algn="ctr" defTabSz="2138324" rtl="0" eaLnBrk="1" latinLnBrk="0" hangingPunct="1">
+              <a:lnSpc>
+                <a:spcPct val="90000"/>
+              </a:lnSpc>
+              <a:spcBef>
+                <a:spcPts val="1169"/>
+              </a:spcBef>
+              <a:buFont typeface="Arial" panose="020B0604020202020204" pitchFamily="34" charset="0"/>
+              <a:buNone/>
+              <a:defRPr sz="4209" kern="1200">
+                <a:solidFill>
+                  <a:schemeClr val="tx1"/>
+                </a:solidFill>
+                <a:latin typeface="Arial" panose="020B0604020202020204" pitchFamily="34" charset="0"/>
+                <a:ea typeface="+mn-ea"/>
+                <a:cs typeface="Arial" panose="020B0604020202020204" pitchFamily="34" charset="0"/>
+              </a:defRPr>
+            </a:lvl3pPr>
+            <a:lvl4pPr marL="3207487" indent="0" algn="ctr" defTabSz="2138324" rtl="0" eaLnBrk="1" latinLnBrk="0" hangingPunct="1">
+              <a:lnSpc>
+                <a:spcPct val="90000"/>
+              </a:lnSpc>
+              <a:spcBef>
+                <a:spcPts val="1169"/>
+              </a:spcBef>
+              <a:buFont typeface="Arial" panose="020B0604020202020204" pitchFamily="34" charset="0"/>
+              <a:buNone/>
+              <a:defRPr sz="3742" kern="1200">
+                <a:solidFill>
+                  <a:schemeClr val="tx1"/>
+                </a:solidFill>
+                <a:latin typeface="Arial" panose="020B0604020202020204" pitchFamily="34" charset="0"/>
+                <a:ea typeface="+mn-ea"/>
+                <a:cs typeface="Arial" panose="020B0604020202020204" pitchFamily="34" charset="0"/>
+              </a:defRPr>
+            </a:lvl4pPr>
+            <a:lvl5pPr marL="4276649" indent="0" algn="ctr" defTabSz="2138324" rtl="0" eaLnBrk="1" latinLnBrk="0" hangingPunct="1">
+              <a:lnSpc>
+                <a:spcPct val="90000"/>
+              </a:lnSpc>
+              <a:spcBef>
+                <a:spcPts val="1169"/>
+              </a:spcBef>
+              <a:buFont typeface="Arial" panose="020B0604020202020204" pitchFamily="34" charset="0"/>
+              <a:buNone/>
+              <a:defRPr sz="3742" kern="1200">
+                <a:solidFill>
+                  <a:schemeClr val="tx1"/>
+                </a:solidFill>
+                <a:latin typeface="Arial" panose="020B0604020202020204" pitchFamily="34" charset="0"/>
+                <a:ea typeface="+mn-ea"/>
+                <a:cs typeface="Arial" panose="020B0604020202020204" pitchFamily="34" charset="0"/>
+              </a:defRPr>
+            </a:lvl5pPr>
+            <a:lvl6pPr marL="5345811" indent="0" algn="ctr" defTabSz="2138324" rtl="0" eaLnBrk="1" latinLnBrk="0" hangingPunct="1">
+              <a:lnSpc>
+                <a:spcPct val="90000"/>
+              </a:lnSpc>
+              <a:spcBef>
+                <a:spcPts val="1169"/>
+              </a:spcBef>
+              <a:buFont typeface="Arial" panose="020B0604020202020204" pitchFamily="34" charset="0"/>
+              <a:buNone/>
+              <a:defRPr sz="3742" kern="1200">
+                <a:solidFill>
+                  <a:schemeClr val="tx1"/>
+                </a:solidFill>
+                <a:latin typeface="+mn-lt"/>
+                <a:ea typeface="+mn-ea"/>
+                <a:cs typeface="+mn-cs"/>
+              </a:defRPr>
+            </a:lvl6pPr>
+            <a:lvl7pPr marL="6414973" indent="0" algn="ctr" defTabSz="2138324" rtl="0" eaLnBrk="1" latinLnBrk="0" hangingPunct="1">
+              <a:lnSpc>
+                <a:spcPct val="90000"/>
+              </a:lnSpc>
+              <a:spcBef>
+                <a:spcPts val="1169"/>
+              </a:spcBef>
+              <a:buFont typeface="Arial" panose="020B0604020202020204" pitchFamily="34" charset="0"/>
+              <a:buNone/>
+              <a:defRPr sz="3742" kern="1200">
+                <a:solidFill>
+                  <a:schemeClr val="tx1"/>
+                </a:solidFill>
+                <a:latin typeface="+mn-lt"/>
+                <a:ea typeface="+mn-ea"/>
+                <a:cs typeface="+mn-cs"/>
+              </a:defRPr>
+            </a:lvl7pPr>
+            <a:lvl8pPr marL="7484135" indent="0" algn="ctr" defTabSz="2138324" rtl="0" eaLnBrk="1" latinLnBrk="0" hangingPunct="1">
+              <a:lnSpc>
+                <a:spcPct val="90000"/>
+              </a:lnSpc>
+              <a:spcBef>
+                <a:spcPts val="1169"/>
+              </a:spcBef>
+              <a:buFont typeface="Arial" panose="020B0604020202020204" pitchFamily="34" charset="0"/>
+              <a:buNone/>
+              <a:defRPr sz="3742" kern="1200">
+                <a:solidFill>
+                  <a:schemeClr val="tx1"/>
+                </a:solidFill>
+                <a:latin typeface="+mn-lt"/>
+                <a:ea typeface="+mn-ea"/>
+                <a:cs typeface="+mn-cs"/>
+              </a:defRPr>
+            </a:lvl8pPr>
+            <a:lvl9pPr marL="8553298" indent="0" algn="ctr" defTabSz="2138324" rtl="0" eaLnBrk="1" latinLnBrk="0" hangingPunct="1">
+              <a:lnSpc>
+                <a:spcPct val="90000"/>
+              </a:lnSpc>
+              <a:spcBef>
+                <a:spcPts val="1169"/>
+              </a:spcBef>
+              <a:buFont typeface="Arial" panose="020B0604020202020204" pitchFamily="34" charset="0"/>
+              <a:buNone/>
+              <a:defRPr sz="3742" kern="1200">
+                <a:solidFill>
+                  <a:schemeClr val="tx1"/>
+                </a:solidFill>
+                <a:latin typeface="+mn-lt"/>
+                <a:ea typeface="+mn-ea"/>
+                <a:cs typeface="+mn-cs"/>
+              </a:defRPr>
+            </a:lvl9pPr>
+          </a:lstStyle>
+          <a:p>
+            <a:pPr algn="just" defTabSz="895518">
+              <a:spcBef>
+                <a:spcPct val="50000"/>
+              </a:spcBef>
+            </a:pPr>
+            <a:r>
+              <a:rPr lang="en-GB" sz="2000" b="0" i="0" noProof="1">
+                <a:solidFill>
+                  <a:srgbClr val="000000"/>
+                </a:solidFill>
+                <a:effectLst/>
+              </a:rPr>
+              <a:t>Box, George; Jenkins, Gwilym (1970). Time Series Analysis: Forecasting and Control. San Francisco: Holden-Day.</a:t>
+            </a:r>
+          </a:p>
+          <a:p>
+            <a:pPr algn="just" defTabSz="895518">
+              <a:spcBef>
+                <a:spcPct val="50000"/>
+              </a:spcBef>
+            </a:pPr>
+            <a:r>
+              <a:rPr lang="en-GB" sz="2000" b="0" i="0" noProof="1">
+                <a:solidFill>
+                  <a:srgbClr val="000000"/>
+                </a:solidFill>
+                <a:effectLst/>
+              </a:rPr>
+              <a:t>Brockwell, Peter J.; Davis, Richard A. (1991). Time Series: Theory and Methods. Springer Verlag.</a:t>
+            </a:r>
+          </a:p>
+          <a:p>
+            <a:pPr algn="just" defTabSz="895518">
+              <a:spcBef>
+                <a:spcPct val="50000"/>
+              </a:spcBef>
+            </a:pPr>
+            <a:r>
+              <a:rPr lang="en-GB" sz="2000" b="0" i="0" noProof="1">
+                <a:solidFill>
+                  <a:srgbClr val="000000"/>
+                </a:solidFill>
+                <a:effectLst/>
+              </a:rPr>
+              <a:t>Commandeur, Jacques J. F.; Koopman, Siem Jan (2007). Introduction to State Space Time Series Analysis. Oxford University Press.</a:t>
+            </a:r>
+          </a:p>
+        </p:txBody>
+      </p:sp>
+      <p:sp>
+        <p:nvSpPr>
+          <p:cNvPr id="9" name="Text Placeholder 2">
+            <a:extLst>
+              <a:ext uri="{FF2B5EF4-FFF2-40B4-BE49-F238E27FC236}">
+                <a16:creationId xmlns:a16="http://schemas.microsoft.com/office/drawing/2014/main" id="{E28BEEEA-4072-E092-A9A9-ADB2BDF8930F}"/>
+              </a:ext>
+            </a:extLst>
+          </p:cNvPr>
+          <p:cNvSpPr txBox="1">
+            <a:spLocks noChangeAspect="1"/>
+          </p:cNvSpPr>
+          <p:nvPr/>
+        </p:nvSpPr>
+        <p:spPr>
+          <a:xfrm>
+            <a:off x="11051852" y="1816126"/>
+            <a:ext cx="9001261" cy="927666"/>
+          </a:xfrm>
+          <a:prstGeom prst="rect">
+            <a:avLst/>
+          </a:prstGeom>
+          <a:solidFill>
+            <a:srgbClr val="00509B"/>
+          </a:solidFill>
+        </p:spPr>
+        <p:txBody>
+          <a:bodyPr vert="horz" lIns="360000" tIns="46800" rIns="108000" bIns="45720" numCol="1" rtlCol="0" anchor="ctr">
+            <a:normAutofit/>
+          </a:bodyPr>
+          <a:lstStyle>
+            <a:lvl1pPr marL="0" indent="0" algn="ctr" defTabSz="2138324" rtl="0" eaLnBrk="1" latinLnBrk="0" hangingPunct="1">
+              <a:lnSpc>
+                <a:spcPct val="90000"/>
+              </a:lnSpc>
+              <a:spcBef>
+                <a:spcPts val="2339"/>
+              </a:spcBef>
+              <a:buFont typeface="Arial" panose="020B0604020202020204" pitchFamily="34" charset="0"/>
+              <a:buNone/>
+              <a:defRPr sz="5612" kern="1200">
+                <a:solidFill>
+                  <a:schemeClr val="tx1"/>
+                </a:solidFill>
+                <a:latin typeface="Arial" panose="020B0604020202020204" pitchFamily="34" charset="0"/>
+                <a:ea typeface="+mn-ea"/>
+                <a:cs typeface="Arial" panose="020B0604020202020204" pitchFamily="34" charset="0"/>
+              </a:defRPr>
+            </a:lvl1pPr>
+            <a:lvl2pPr marL="1069162" indent="0" algn="ctr" defTabSz="2138324" rtl="0" eaLnBrk="1" latinLnBrk="0" hangingPunct="1">
+              <a:lnSpc>
+                <a:spcPct val="90000"/>
+              </a:lnSpc>
+              <a:spcBef>
+                <a:spcPts val="1169"/>
+              </a:spcBef>
+              <a:buFont typeface="Arial" panose="020B0604020202020204" pitchFamily="34" charset="0"/>
+              <a:buNone/>
+              <a:defRPr sz="4677" kern="1200">
+                <a:solidFill>
+                  <a:schemeClr val="tx1"/>
+                </a:solidFill>
+                <a:latin typeface="Arial" panose="020B0604020202020204" pitchFamily="34" charset="0"/>
+                <a:ea typeface="+mn-ea"/>
+                <a:cs typeface="Arial" panose="020B0604020202020204" pitchFamily="34" charset="0"/>
+              </a:defRPr>
+            </a:lvl2pPr>
+            <a:lvl3pPr marL="2138324" indent="0" algn="ctr" defTabSz="2138324" rtl="0" eaLnBrk="1" latinLnBrk="0" hangingPunct="1">
+              <a:lnSpc>
+                <a:spcPct val="90000"/>
+              </a:lnSpc>
+              <a:spcBef>
+                <a:spcPts val="1169"/>
+              </a:spcBef>
+              <a:buFont typeface="Arial" panose="020B0604020202020204" pitchFamily="34" charset="0"/>
+              <a:buNone/>
+              <a:defRPr sz="4209" kern="1200">
+                <a:solidFill>
+                  <a:schemeClr val="tx1"/>
+                </a:solidFill>
+                <a:latin typeface="Arial" panose="020B0604020202020204" pitchFamily="34" charset="0"/>
+                <a:ea typeface="+mn-ea"/>
+                <a:cs typeface="Arial" panose="020B0604020202020204" pitchFamily="34" charset="0"/>
+              </a:defRPr>
+            </a:lvl3pPr>
+            <a:lvl4pPr marL="3207487" indent="0" algn="ctr" defTabSz="2138324" rtl="0" eaLnBrk="1" latinLnBrk="0" hangingPunct="1">
+              <a:lnSpc>
+                <a:spcPct val="90000"/>
+              </a:lnSpc>
+              <a:spcBef>
+                <a:spcPts val="1169"/>
+              </a:spcBef>
+              <a:buFont typeface="Arial" panose="020B0604020202020204" pitchFamily="34" charset="0"/>
+              <a:buNone/>
+              <a:defRPr sz="3742" kern="1200">
+                <a:solidFill>
+                  <a:schemeClr val="tx1"/>
+                </a:solidFill>
+                <a:latin typeface="Arial" panose="020B0604020202020204" pitchFamily="34" charset="0"/>
+                <a:ea typeface="+mn-ea"/>
+                <a:cs typeface="Arial" panose="020B0604020202020204" pitchFamily="34" charset="0"/>
+              </a:defRPr>
+            </a:lvl4pPr>
+            <a:lvl5pPr marL="4276649" indent="0" algn="ctr" defTabSz="2138324" rtl="0" eaLnBrk="1" latinLnBrk="0" hangingPunct="1">
+              <a:lnSpc>
+                <a:spcPct val="90000"/>
+              </a:lnSpc>
+              <a:spcBef>
+                <a:spcPts val="1169"/>
+              </a:spcBef>
+              <a:buFont typeface="Arial" panose="020B0604020202020204" pitchFamily="34" charset="0"/>
+              <a:buNone/>
+              <a:defRPr sz="3742" kern="1200">
+                <a:solidFill>
+                  <a:schemeClr val="tx1"/>
+                </a:solidFill>
+                <a:latin typeface="Arial" panose="020B0604020202020204" pitchFamily="34" charset="0"/>
+                <a:ea typeface="+mn-ea"/>
+                <a:cs typeface="Arial" panose="020B0604020202020204" pitchFamily="34" charset="0"/>
+              </a:defRPr>
+            </a:lvl5pPr>
+            <a:lvl6pPr marL="5345811" indent="0" algn="ctr" defTabSz="2138324" rtl="0" eaLnBrk="1" latinLnBrk="0" hangingPunct="1">
+              <a:lnSpc>
+                <a:spcPct val="90000"/>
+              </a:lnSpc>
+              <a:spcBef>
+                <a:spcPts val="1169"/>
+              </a:spcBef>
+              <a:buFont typeface="Arial" panose="020B0604020202020204" pitchFamily="34" charset="0"/>
+              <a:buNone/>
+              <a:defRPr sz="3742" kern="1200">
+                <a:solidFill>
+                  <a:schemeClr val="tx1"/>
+                </a:solidFill>
+                <a:latin typeface="+mn-lt"/>
+                <a:ea typeface="+mn-ea"/>
+                <a:cs typeface="+mn-cs"/>
+              </a:defRPr>
+            </a:lvl6pPr>
+            <a:lvl7pPr marL="6414973" indent="0" algn="ctr" defTabSz="2138324" rtl="0" eaLnBrk="1" latinLnBrk="0" hangingPunct="1">
+              <a:lnSpc>
+                <a:spcPct val="90000"/>
+              </a:lnSpc>
+              <a:spcBef>
+                <a:spcPts val="1169"/>
+              </a:spcBef>
+              <a:buFont typeface="Arial" panose="020B0604020202020204" pitchFamily="34" charset="0"/>
+              <a:buNone/>
+              <a:defRPr sz="3742" kern="1200">
+                <a:solidFill>
+                  <a:schemeClr val="tx1"/>
+                </a:solidFill>
+                <a:latin typeface="+mn-lt"/>
+                <a:ea typeface="+mn-ea"/>
+                <a:cs typeface="+mn-cs"/>
+              </a:defRPr>
+            </a:lvl7pPr>
+            <a:lvl8pPr marL="7484135" indent="0" algn="ctr" defTabSz="2138324" rtl="0" eaLnBrk="1" latinLnBrk="0" hangingPunct="1">
+              <a:lnSpc>
+                <a:spcPct val="90000"/>
+              </a:lnSpc>
+              <a:spcBef>
+                <a:spcPts val="1169"/>
+              </a:spcBef>
+              <a:buFont typeface="Arial" panose="020B0604020202020204" pitchFamily="34" charset="0"/>
+              <a:buNone/>
+              <a:defRPr sz="3742" kern="1200">
+                <a:solidFill>
+                  <a:schemeClr val="tx1"/>
+                </a:solidFill>
+                <a:latin typeface="+mn-lt"/>
+                <a:ea typeface="+mn-ea"/>
+                <a:cs typeface="+mn-cs"/>
+              </a:defRPr>
+            </a:lvl8pPr>
+            <a:lvl9pPr marL="8553298" indent="0" algn="ctr" defTabSz="2138324" rtl="0" eaLnBrk="1" latinLnBrk="0" hangingPunct="1">
+              <a:lnSpc>
+                <a:spcPct val="90000"/>
+              </a:lnSpc>
+              <a:spcBef>
+                <a:spcPts val="1169"/>
+              </a:spcBef>
+              <a:buFont typeface="Arial" panose="020B0604020202020204" pitchFamily="34" charset="0"/>
+              <a:buNone/>
+              <a:defRPr sz="3742" kern="1200">
+                <a:solidFill>
+                  <a:schemeClr val="tx1"/>
+                </a:solidFill>
+                <a:latin typeface="+mn-lt"/>
+                <a:ea typeface="+mn-ea"/>
+                <a:cs typeface="+mn-cs"/>
+              </a:defRPr>
+            </a:lvl9pPr>
+          </a:lstStyle>
+          <a:p>
+            <a:pPr algn="l"/>
+            <a:r>
+              <a:rPr lang="de-DE" sz="3200" b="1" dirty="0">
+                <a:solidFill>
+                  <a:schemeClr val="bg1"/>
+                </a:solidFill>
+              </a:rPr>
+              <a:t>Anhang</a:t>
+            </a:r>
+          </a:p>
+        </p:txBody>
+      </p:sp>
+      <p:sp>
+        <p:nvSpPr>
+          <p:cNvPr id="12" name="Text Placeholder 2">
+            <a:extLst>
+              <a:ext uri="{FF2B5EF4-FFF2-40B4-BE49-F238E27FC236}">
+                <a16:creationId xmlns:a16="http://schemas.microsoft.com/office/drawing/2014/main" id="{98F8B74D-0607-C4F5-12CA-79BABBD4F671}"/>
+              </a:ext>
+            </a:extLst>
+          </p:cNvPr>
+          <p:cNvSpPr txBox="1">
+            <a:spLocks/>
+          </p:cNvSpPr>
+          <p:nvPr/>
+        </p:nvSpPr>
+        <p:spPr>
+          <a:xfrm>
+            <a:off x="11051852" y="2935033"/>
+            <a:ext cx="9001260" cy="12011332"/>
+          </a:xfrm>
+          <a:prstGeom prst="rect">
+            <a:avLst/>
+          </a:prstGeom>
+          <a:solidFill>
+            <a:schemeClr val="bg1">
+              <a:lumMod val="95000"/>
+            </a:schemeClr>
+          </a:solidFill>
+        </p:spPr>
+        <p:txBody>
+          <a:bodyPr vert="horz" lIns="360000" tIns="360000" rIns="360000" bIns="360000" numCol="1" rtlCol="0">
+            <a:noAutofit/>
+          </a:bodyPr>
+          <a:lstStyle>
+            <a:lvl1pPr marL="0" indent="0" algn="ctr" defTabSz="2138324" rtl="0" eaLnBrk="1" latinLnBrk="0" hangingPunct="1">
+              <a:lnSpc>
+                <a:spcPct val="90000"/>
+              </a:lnSpc>
+              <a:spcBef>
+                <a:spcPts val="2339"/>
+              </a:spcBef>
+              <a:buFont typeface="Arial" panose="020B0604020202020204" pitchFamily="34" charset="0"/>
+              <a:buNone/>
+              <a:defRPr sz="5612" kern="1200">
+                <a:solidFill>
+                  <a:schemeClr val="tx1"/>
+                </a:solidFill>
+                <a:latin typeface="Arial" panose="020B0604020202020204" pitchFamily="34" charset="0"/>
+                <a:ea typeface="+mn-ea"/>
+                <a:cs typeface="Arial" panose="020B0604020202020204" pitchFamily="34" charset="0"/>
+              </a:defRPr>
+            </a:lvl1pPr>
+            <a:lvl2pPr marL="1069162" indent="0" algn="ctr" defTabSz="2138324" rtl="0" eaLnBrk="1" latinLnBrk="0" hangingPunct="1">
+              <a:lnSpc>
+                <a:spcPct val="90000"/>
+              </a:lnSpc>
+              <a:spcBef>
+                <a:spcPts val="1169"/>
+              </a:spcBef>
+              <a:buFont typeface="Arial" panose="020B0604020202020204" pitchFamily="34" charset="0"/>
+              <a:buNone/>
+              <a:defRPr sz="4677" kern="1200">
+                <a:solidFill>
+                  <a:schemeClr val="tx1"/>
+                </a:solidFill>
+                <a:latin typeface="Arial" panose="020B0604020202020204" pitchFamily="34" charset="0"/>
+                <a:ea typeface="+mn-ea"/>
+                <a:cs typeface="Arial" panose="020B0604020202020204" pitchFamily="34" charset="0"/>
+              </a:defRPr>
+            </a:lvl2pPr>
+            <a:lvl3pPr marL="2138324" indent="0" algn="ctr" defTabSz="2138324" rtl="0" eaLnBrk="1" latinLnBrk="0" hangingPunct="1">
+              <a:lnSpc>
+                <a:spcPct val="90000"/>
+              </a:lnSpc>
+              <a:spcBef>
+                <a:spcPts val="1169"/>
+              </a:spcBef>
+              <a:buFont typeface="Arial" panose="020B0604020202020204" pitchFamily="34" charset="0"/>
+              <a:buNone/>
+              <a:defRPr sz="4209" kern="1200">
+                <a:solidFill>
+                  <a:schemeClr val="tx1"/>
+                </a:solidFill>
+                <a:latin typeface="Arial" panose="020B0604020202020204" pitchFamily="34" charset="0"/>
+                <a:ea typeface="+mn-ea"/>
+                <a:cs typeface="Arial" panose="020B0604020202020204" pitchFamily="34" charset="0"/>
+              </a:defRPr>
+            </a:lvl3pPr>
+            <a:lvl4pPr marL="3207487" indent="0" algn="ctr" defTabSz="2138324" rtl="0" eaLnBrk="1" latinLnBrk="0" hangingPunct="1">
+              <a:lnSpc>
+                <a:spcPct val="90000"/>
+              </a:lnSpc>
+              <a:spcBef>
+                <a:spcPts val="1169"/>
+              </a:spcBef>
+              <a:buFont typeface="Arial" panose="020B0604020202020204" pitchFamily="34" charset="0"/>
+              <a:buNone/>
+              <a:defRPr sz="3742" kern="1200">
+                <a:solidFill>
+                  <a:schemeClr val="tx1"/>
+                </a:solidFill>
+                <a:latin typeface="Arial" panose="020B0604020202020204" pitchFamily="34" charset="0"/>
+                <a:ea typeface="+mn-ea"/>
+                <a:cs typeface="Arial" panose="020B0604020202020204" pitchFamily="34" charset="0"/>
+              </a:defRPr>
+            </a:lvl4pPr>
+            <a:lvl5pPr marL="4276649" indent="0" algn="ctr" defTabSz="2138324" rtl="0" eaLnBrk="1" latinLnBrk="0" hangingPunct="1">
+              <a:lnSpc>
+                <a:spcPct val="90000"/>
+              </a:lnSpc>
+              <a:spcBef>
+                <a:spcPts val="1169"/>
+              </a:spcBef>
+              <a:buFont typeface="Arial" panose="020B0604020202020204" pitchFamily="34" charset="0"/>
+              <a:buNone/>
+              <a:defRPr sz="3742" kern="1200">
+                <a:solidFill>
+                  <a:schemeClr val="tx1"/>
+                </a:solidFill>
+                <a:latin typeface="Arial" panose="020B0604020202020204" pitchFamily="34" charset="0"/>
+                <a:ea typeface="+mn-ea"/>
+                <a:cs typeface="Arial" panose="020B0604020202020204" pitchFamily="34" charset="0"/>
+              </a:defRPr>
+            </a:lvl5pPr>
+            <a:lvl6pPr marL="5345811" indent="0" algn="ctr" defTabSz="2138324" rtl="0" eaLnBrk="1" latinLnBrk="0" hangingPunct="1">
+              <a:lnSpc>
+                <a:spcPct val="90000"/>
+              </a:lnSpc>
+              <a:spcBef>
+                <a:spcPts val="1169"/>
+              </a:spcBef>
+              <a:buFont typeface="Arial" panose="020B0604020202020204" pitchFamily="34" charset="0"/>
+              <a:buNone/>
+              <a:defRPr sz="3742" kern="1200">
+                <a:solidFill>
+                  <a:schemeClr val="tx1"/>
+                </a:solidFill>
+                <a:latin typeface="+mn-lt"/>
+                <a:ea typeface="+mn-ea"/>
+                <a:cs typeface="+mn-cs"/>
+              </a:defRPr>
+            </a:lvl6pPr>
+            <a:lvl7pPr marL="6414973" indent="0" algn="ctr" defTabSz="2138324" rtl="0" eaLnBrk="1" latinLnBrk="0" hangingPunct="1">
+              <a:lnSpc>
+                <a:spcPct val="90000"/>
+              </a:lnSpc>
+              <a:spcBef>
+                <a:spcPts val="1169"/>
+              </a:spcBef>
+              <a:buFont typeface="Arial" panose="020B0604020202020204" pitchFamily="34" charset="0"/>
+              <a:buNone/>
+              <a:defRPr sz="3742" kern="1200">
+                <a:solidFill>
+                  <a:schemeClr val="tx1"/>
+                </a:solidFill>
+                <a:latin typeface="+mn-lt"/>
+                <a:ea typeface="+mn-ea"/>
+                <a:cs typeface="+mn-cs"/>
+              </a:defRPr>
+            </a:lvl7pPr>
+            <a:lvl8pPr marL="7484135" indent="0" algn="ctr" defTabSz="2138324" rtl="0" eaLnBrk="1" latinLnBrk="0" hangingPunct="1">
+              <a:lnSpc>
+                <a:spcPct val="90000"/>
+              </a:lnSpc>
+              <a:spcBef>
+                <a:spcPts val="1169"/>
+              </a:spcBef>
+              <a:buFont typeface="Arial" panose="020B0604020202020204" pitchFamily="34" charset="0"/>
+              <a:buNone/>
+              <a:defRPr sz="3742" kern="1200">
+                <a:solidFill>
+                  <a:schemeClr val="tx1"/>
+                </a:solidFill>
+                <a:latin typeface="+mn-lt"/>
+                <a:ea typeface="+mn-ea"/>
+                <a:cs typeface="+mn-cs"/>
+              </a:defRPr>
+            </a:lvl8pPr>
+            <a:lvl9pPr marL="8553298" indent="0" algn="ctr" defTabSz="2138324" rtl="0" eaLnBrk="1" latinLnBrk="0" hangingPunct="1">
+              <a:lnSpc>
+                <a:spcPct val="90000"/>
+              </a:lnSpc>
+              <a:spcBef>
+                <a:spcPts val="1169"/>
+              </a:spcBef>
+              <a:buFont typeface="Arial" panose="020B0604020202020204" pitchFamily="34" charset="0"/>
+              <a:buNone/>
+              <a:defRPr sz="3742" kern="1200">
+                <a:solidFill>
+                  <a:schemeClr val="tx1"/>
+                </a:solidFill>
+                <a:latin typeface="+mn-lt"/>
+                <a:ea typeface="+mn-ea"/>
+                <a:cs typeface="+mn-cs"/>
+              </a:defRPr>
+            </a:lvl9pPr>
+          </a:lstStyle>
+          <a:p>
+            <a:pPr algn="just" defTabSz="895518">
+              <a:spcBef>
+                <a:spcPct val="50000"/>
+              </a:spcBef>
+            </a:pPr>
+            <a:r>
+              <a:rPr lang="en-GB" sz="2000" b="0" i="0" noProof="1">
+                <a:solidFill>
+                  <a:srgbClr val="000000"/>
+                </a:solidFill>
+                <a:effectLst/>
+              </a:rPr>
+              <a:t>Lorem ipsum</a:t>
+            </a:r>
+          </a:p>
+        </p:txBody>
+      </p:sp>
+      <p:sp>
+        <p:nvSpPr>
+          <p:cNvPr id="20" name="Text Placeholder 2">
+            <a:extLst>
+              <a:ext uri="{FF2B5EF4-FFF2-40B4-BE49-F238E27FC236}">
+                <a16:creationId xmlns:a16="http://schemas.microsoft.com/office/drawing/2014/main" id="{058E4438-CD95-6B5C-2402-AC0EE3629B5B}"/>
+              </a:ext>
+            </a:extLst>
+          </p:cNvPr>
+          <p:cNvSpPr txBox="1">
+            <a:spLocks noChangeAspect="1"/>
+          </p:cNvSpPr>
+          <p:nvPr/>
+        </p:nvSpPr>
+        <p:spPr>
+          <a:xfrm>
+            <a:off x="11052039" y="15137606"/>
+            <a:ext cx="9001261" cy="927666"/>
+          </a:xfrm>
+          <a:prstGeom prst="rect">
+            <a:avLst/>
+          </a:prstGeom>
+          <a:solidFill>
+            <a:srgbClr val="00509B"/>
+          </a:solidFill>
+        </p:spPr>
+        <p:txBody>
+          <a:bodyPr vert="horz" lIns="360000" tIns="46800" rIns="108000" bIns="45720" numCol="1" rtlCol="0" anchor="ctr">
+            <a:normAutofit/>
+          </a:bodyPr>
+          <a:lstStyle>
+            <a:lvl1pPr marL="0" indent="0" algn="ctr" defTabSz="2138324" rtl="0" eaLnBrk="1" latinLnBrk="0" hangingPunct="1">
+              <a:lnSpc>
+                <a:spcPct val="90000"/>
+              </a:lnSpc>
+              <a:spcBef>
+                <a:spcPts val="2339"/>
+              </a:spcBef>
+              <a:buFont typeface="Arial" panose="020B0604020202020204" pitchFamily="34" charset="0"/>
+              <a:buNone/>
+              <a:defRPr sz="5612" kern="1200">
+                <a:solidFill>
+                  <a:schemeClr val="tx1"/>
+                </a:solidFill>
+                <a:latin typeface="Arial" panose="020B0604020202020204" pitchFamily="34" charset="0"/>
+                <a:ea typeface="+mn-ea"/>
+                <a:cs typeface="Arial" panose="020B0604020202020204" pitchFamily="34" charset="0"/>
+              </a:defRPr>
+            </a:lvl1pPr>
+            <a:lvl2pPr marL="1069162" indent="0" algn="ctr" defTabSz="2138324" rtl="0" eaLnBrk="1" latinLnBrk="0" hangingPunct="1">
+              <a:lnSpc>
+                <a:spcPct val="90000"/>
+              </a:lnSpc>
+              <a:spcBef>
+                <a:spcPts val="1169"/>
+              </a:spcBef>
+              <a:buFont typeface="Arial" panose="020B0604020202020204" pitchFamily="34" charset="0"/>
+              <a:buNone/>
+              <a:defRPr sz="4677" kern="1200">
+                <a:solidFill>
+                  <a:schemeClr val="tx1"/>
+                </a:solidFill>
+                <a:latin typeface="Arial" panose="020B0604020202020204" pitchFamily="34" charset="0"/>
+                <a:ea typeface="+mn-ea"/>
+                <a:cs typeface="Arial" panose="020B0604020202020204" pitchFamily="34" charset="0"/>
+              </a:defRPr>
+            </a:lvl2pPr>
+            <a:lvl3pPr marL="2138324" indent="0" algn="ctr" defTabSz="2138324" rtl="0" eaLnBrk="1" latinLnBrk="0" hangingPunct="1">
+              <a:lnSpc>
+                <a:spcPct val="90000"/>
+              </a:lnSpc>
+              <a:spcBef>
+                <a:spcPts val="1169"/>
+              </a:spcBef>
+              <a:buFont typeface="Arial" panose="020B0604020202020204" pitchFamily="34" charset="0"/>
+              <a:buNone/>
+              <a:defRPr sz="4209" kern="1200">
+                <a:solidFill>
+                  <a:schemeClr val="tx1"/>
+                </a:solidFill>
+                <a:latin typeface="Arial" panose="020B0604020202020204" pitchFamily="34" charset="0"/>
+                <a:ea typeface="+mn-ea"/>
+                <a:cs typeface="Arial" panose="020B0604020202020204" pitchFamily="34" charset="0"/>
+              </a:defRPr>
+            </a:lvl3pPr>
+            <a:lvl4pPr marL="3207487" indent="0" algn="ctr" defTabSz="2138324" rtl="0" eaLnBrk="1" latinLnBrk="0" hangingPunct="1">
+              <a:lnSpc>
+                <a:spcPct val="90000"/>
+              </a:lnSpc>
+              <a:spcBef>
+                <a:spcPts val="1169"/>
+              </a:spcBef>
+              <a:buFont typeface="Arial" panose="020B0604020202020204" pitchFamily="34" charset="0"/>
+              <a:buNone/>
+              <a:defRPr sz="3742" kern="1200">
+                <a:solidFill>
+                  <a:schemeClr val="tx1"/>
+                </a:solidFill>
+                <a:latin typeface="Arial" panose="020B0604020202020204" pitchFamily="34" charset="0"/>
+                <a:ea typeface="+mn-ea"/>
+                <a:cs typeface="Arial" panose="020B0604020202020204" pitchFamily="34" charset="0"/>
+              </a:defRPr>
+            </a:lvl4pPr>
+            <a:lvl5pPr marL="4276649" indent="0" algn="ctr" defTabSz="2138324" rtl="0" eaLnBrk="1" latinLnBrk="0" hangingPunct="1">
+              <a:lnSpc>
+                <a:spcPct val="90000"/>
+              </a:lnSpc>
+              <a:spcBef>
+                <a:spcPts val="1169"/>
+              </a:spcBef>
+              <a:buFont typeface="Arial" panose="020B0604020202020204" pitchFamily="34" charset="0"/>
+              <a:buNone/>
+              <a:defRPr sz="3742" kern="1200">
+                <a:solidFill>
+                  <a:schemeClr val="tx1"/>
+                </a:solidFill>
+                <a:latin typeface="Arial" panose="020B0604020202020204" pitchFamily="34" charset="0"/>
+                <a:ea typeface="+mn-ea"/>
+                <a:cs typeface="Arial" panose="020B0604020202020204" pitchFamily="34" charset="0"/>
+              </a:defRPr>
+            </a:lvl5pPr>
+            <a:lvl6pPr marL="5345811" indent="0" algn="ctr" defTabSz="2138324" rtl="0" eaLnBrk="1" latinLnBrk="0" hangingPunct="1">
+              <a:lnSpc>
+                <a:spcPct val="90000"/>
+              </a:lnSpc>
+              <a:spcBef>
+                <a:spcPts val="1169"/>
+              </a:spcBef>
+              <a:buFont typeface="Arial" panose="020B0604020202020204" pitchFamily="34" charset="0"/>
+              <a:buNone/>
+              <a:defRPr sz="3742" kern="1200">
+                <a:solidFill>
+                  <a:schemeClr val="tx1"/>
+                </a:solidFill>
+                <a:latin typeface="+mn-lt"/>
+                <a:ea typeface="+mn-ea"/>
+                <a:cs typeface="+mn-cs"/>
+              </a:defRPr>
+            </a:lvl6pPr>
+            <a:lvl7pPr marL="6414973" indent="0" algn="ctr" defTabSz="2138324" rtl="0" eaLnBrk="1" latinLnBrk="0" hangingPunct="1">
+              <a:lnSpc>
+                <a:spcPct val="90000"/>
+              </a:lnSpc>
+              <a:spcBef>
+                <a:spcPts val="1169"/>
+              </a:spcBef>
+              <a:buFont typeface="Arial" panose="020B0604020202020204" pitchFamily="34" charset="0"/>
+              <a:buNone/>
+              <a:defRPr sz="3742" kern="1200">
+                <a:solidFill>
+                  <a:schemeClr val="tx1"/>
+                </a:solidFill>
+                <a:latin typeface="+mn-lt"/>
+                <a:ea typeface="+mn-ea"/>
+                <a:cs typeface="+mn-cs"/>
+              </a:defRPr>
+            </a:lvl7pPr>
+            <a:lvl8pPr marL="7484135" indent="0" algn="ctr" defTabSz="2138324" rtl="0" eaLnBrk="1" latinLnBrk="0" hangingPunct="1">
+              <a:lnSpc>
+                <a:spcPct val="90000"/>
+              </a:lnSpc>
+              <a:spcBef>
+                <a:spcPts val="1169"/>
+              </a:spcBef>
+              <a:buFont typeface="Arial" panose="020B0604020202020204" pitchFamily="34" charset="0"/>
+              <a:buNone/>
+              <a:defRPr sz="3742" kern="1200">
+                <a:solidFill>
+                  <a:schemeClr val="tx1"/>
+                </a:solidFill>
+                <a:latin typeface="+mn-lt"/>
+                <a:ea typeface="+mn-ea"/>
+                <a:cs typeface="+mn-cs"/>
+              </a:defRPr>
+            </a:lvl8pPr>
+            <a:lvl9pPr marL="8553298" indent="0" algn="ctr" defTabSz="2138324" rtl="0" eaLnBrk="1" latinLnBrk="0" hangingPunct="1">
+              <a:lnSpc>
+                <a:spcPct val="90000"/>
+              </a:lnSpc>
+              <a:spcBef>
+                <a:spcPts val="1169"/>
+              </a:spcBef>
+              <a:buFont typeface="Arial" panose="020B0604020202020204" pitchFamily="34" charset="0"/>
+              <a:buNone/>
+              <a:defRPr sz="3742" kern="1200">
+                <a:solidFill>
+                  <a:schemeClr val="tx1"/>
+                </a:solidFill>
+                <a:latin typeface="+mn-lt"/>
+                <a:ea typeface="+mn-ea"/>
+                <a:cs typeface="+mn-cs"/>
+              </a:defRPr>
+            </a:lvl9pPr>
+          </a:lstStyle>
+          <a:p>
+            <a:pPr algn="l"/>
+            <a:r>
+              <a:rPr lang="de-DE" sz="3200" b="1" dirty="0">
+                <a:solidFill>
+                  <a:schemeClr val="bg1"/>
+                </a:solidFill>
+              </a:rPr>
+              <a:t>Ehrenwörtliche Erklärung</a:t>
+            </a:r>
+          </a:p>
+        </p:txBody>
+      </p:sp>
+      <p:sp>
+        <p:nvSpPr>
+          <p:cNvPr id="21" name="Text Placeholder 2">
+            <a:extLst>
+              <a:ext uri="{FF2B5EF4-FFF2-40B4-BE49-F238E27FC236}">
+                <a16:creationId xmlns:a16="http://schemas.microsoft.com/office/drawing/2014/main" id="{E8F34CCE-AA2A-D1CE-0828-0663FFB9E312}"/>
+              </a:ext>
+            </a:extLst>
+          </p:cNvPr>
+          <p:cNvSpPr txBox="1">
+            <a:spLocks/>
+          </p:cNvSpPr>
+          <p:nvPr/>
+        </p:nvSpPr>
+        <p:spPr>
+          <a:xfrm>
+            <a:off x="11052039" y="16256513"/>
+            <a:ext cx="9001260" cy="4857757"/>
+          </a:xfrm>
+          <a:prstGeom prst="rect">
+            <a:avLst/>
+          </a:prstGeom>
+          <a:solidFill>
+            <a:schemeClr val="bg1">
+              <a:lumMod val="95000"/>
+            </a:schemeClr>
+          </a:solidFill>
+        </p:spPr>
+        <p:txBody>
+          <a:bodyPr vert="horz" lIns="360000" tIns="360000" rIns="360000" bIns="360000" numCol="1" rtlCol="0">
+            <a:noAutofit/>
+          </a:bodyPr>
+          <a:lstStyle>
+            <a:lvl1pPr marL="0" indent="0" algn="ctr" defTabSz="2138324" rtl="0" eaLnBrk="1" latinLnBrk="0" hangingPunct="1">
+              <a:lnSpc>
+                <a:spcPct val="90000"/>
+              </a:lnSpc>
+              <a:spcBef>
+                <a:spcPts val="2339"/>
+              </a:spcBef>
+              <a:buFont typeface="Arial" panose="020B0604020202020204" pitchFamily="34" charset="0"/>
+              <a:buNone/>
+              <a:defRPr sz="5612" kern="1200">
+                <a:solidFill>
+                  <a:schemeClr val="tx1"/>
+                </a:solidFill>
+                <a:latin typeface="Arial" panose="020B0604020202020204" pitchFamily="34" charset="0"/>
+                <a:ea typeface="+mn-ea"/>
+                <a:cs typeface="Arial" panose="020B0604020202020204" pitchFamily="34" charset="0"/>
+              </a:defRPr>
+            </a:lvl1pPr>
+            <a:lvl2pPr marL="1069162" indent="0" algn="ctr" defTabSz="2138324" rtl="0" eaLnBrk="1" latinLnBrk="0" hangingPunct="1">
+              <a:lnSpc>
+                <a:spcPct val="90000"/>
+              </a:lnSpc>
+              <a:spcBef>
+                <a:spcPts val="1169"/>
+              </a:spcBef>
+              <a:buFont typeface="Arial" panose="020B0604020202020204" pitchFamily="34" charset="0"/>
+              <a:buNone/>
+              <a:defRPr sz="4677" kern="1200">
+                <a:solidFill>
+                  <a:schemeClr val="tx1"/>
+                </a:solidFill>
+                <a:latin typeface="Arial" panose="020B0604020202020204" pitchFamily="34" charset="0"/>
+                <a:ea typeface="+mn-ea"/>
+                <a:cs typeface="Arial" panose="020B0604020202020204" pitchFamily="34" charset="0"/>
+              </a:defRPr>
+            </a:lvl2pPr>
+            <a:lvl3pPr marL="2138324" indent="0" algn="ctr" defTabSz="2138324" rtl="0" eaLnBrk="1" latinLnBrk="0" hangingPunct="1">
+              <a:lnSpc>
+                <a:spcPct val="90000"/>
+              </a:lnSpc>
+              <a:spcBef>
+                <a:spcPts val="1169"/>
+              </a:spcBef>
+              <a:buFont typeface="Arial" panose="020B0604020202020204" pitchFamily="34" charset="0"/>
+              <a:buNone/>
+              <a:defRPr sz="4209" kern="1200">
+                <a:solidFill>
+                  <a:schemeClr val="tx1"/>
+                </a:solidFill>
+                <a:latin typeface="Arial" panose="020B0604020202020204" pitchFamily="34" charset="0"/>
+                <a:ea typeface="+mn-ea"/>
+                <a:cs typeface="Arial" panose="020B0604020202020204" pitchFamily="34" charset="0"/>
+              </a:defRPr>
+            </a:lvl3pPr>
+            <a:lvl4pPr marL="3207487" indent="0" algn="ctr" defTabSz="2138324" rtl="0" eaLnBrk="1" latinLnBrk="0" hangingPunct="1">
+              <a:lnSpc>
+                <a:spcPct val="90000"/>
+              </a:lnSpc>
+              <a:spcBef>
+                <a:spcPts val="1169"/>
+              </a:spcBef>
+              <a:buFont typeface="Arial" panose="020B0604020202020204" pitchFamily="34" charset="0"/>
+              <a:buNone/>
+              <a:defRPr sz="3742" kern="1200">
+                <a:solidFill>
+                  <a:schemeClr val="tx1"/>
+                </a:solidFill>
+                <a:latin typeface="Arial" panose="020B0604020202020204" pitchFamily="34" charset="0"/>
+                <a:ea typeface="+mn-ea"/>
+                <a:cs typeface="Arial" panose="020B0604020202020204" pitchFamily="34" charset="0"/>
+              </a:defRPr>
+            </a:lvl4pPr>
+            <a:lvl5pPr marL="4276649" indent="0" algn="ctr" defTabSz="2138324" rtl="0" eaLnBrk="1" latinLnBrk="0" hangingPunct="1">
+              <a:lnSpc>
+                <a:spcPct val="90000"/>
+              </a:lnSpc>
+              <a:spcBef>
+                <a:spcPts val="1169"/>
+              </a:spcBef>
+              <a:buFont typeface="Arial" panose="020B0604020202020204" pitchFamily="34" charset="0"/>
+              <a:buNone/>
+              <a:defRPr sz="3742" kern="1200">
+                <a:solidFill>
+                  <a:schemeClr val="tx1"/>
+                </a:solidFill>
+                <a:latin typeface="Arial" panose="020B0604020202020204" pitchFamily="34" charset="0"/>
+                <a:ea typeface="+mn-ea"/>
+                <a:cs typeface="Arial" panose="020B0604020202020204" pitchFamily="34" charset="0"/>
+              </a:defRPr>
+            </a:lvl5pPr>
+            <a:lvl6pPr marL="5345811" indent="0" algn="ctr" defTabSz="2138324" rtl="0" eaLnBrk="1" latinLnBrk="0" hangingPunct="1">
+              <a:lnSpc>
+                <a:spcPct val="90000"/>
+              </a:lnSpc>
+              <a:spcBef>
+                <a:spcPts val="1169"/>
+              </a:spcBef>
+              <a:buFont typeface="Arial" panose="020B0604020202020204" pitchFamily="34" charset="0"/>
+              <a:buNone/>
+              <a:defRPr sz="3742" kern="1200">
+                <a:solidFill>
+                  <a:schemeClr val="tx1"/>
+                </a:solidFill>
+                <a:latin typeface="+mn-lt"/>
+                <a:ea typeface="+mn-ea"/>
+                <a:cs typeface="+mn-cs"/>
+              </a:defRPr>
+            </a:lvl6pPr>
+            <a:lvl7pPr marL="6414973" indent="0" algn="ctr" defTabSz="2138324" rtl="0" eaLnBrk="1" latinLnBrk="0" hangingPunct="1">
+              <a:lnSpc>
+                <a:spcPct val="90000"/>
+              </a:lnSpc>
+              <a:spcBef>
+                <a:spcPts val="1169"/>
+              </a:spcBef>
+              <a:buFont typeface="Arial" panose="020B0604020202020204" pitchFamily="34" charset="0"/>
+              <a:buNone/>
+              <a:defRPr sz="3742" kern="1200">
+                <a:solidFill>
+                  <a:schemeClr val="tx1"/>
+                </a:solidFill>
+                <a:latin typeface="+mn-lt"/>
+                <a:ea typeface="+mn-ea"/>
+                <a:cs typeface="+mn-cs"/>
+              </a:defRPr>
+            </a:lvl7pPr>
+            <a:lvl8pPr marL="7484135" indent="0" algn="ctr" defTabSz="2138324" rtl="0" eaLnBrk="1" latinLnBrk="0" hangingPunct="1">
+              <a:lnSpc>
+                <a:spcPct val="90000"/>
+              </a:lnSpc>
+              <a:spcBef>
+                <a:spcPts val="1169"/>
+              </a:spcBef>
+              <a:buFont typeface="Arial" panose="020B0604020202020204" pitchFamily="34" charset="0"/>
+              <a:buNone/>
+              <a:defRPr sz="3742" kern="1200">
+                <a:solidFill>
+                  <a:schemeClr val="tx1"/>
+                </a:solidFill>
+                <a:latin typeface="+mn-lt"/>
+                <a:ea typeface="+mn-ea"/>
+                <a:cs typeface="+mn-cs"/>
+              </a:defRPr>
+            </a:lvl8pPr>
+            <a:lvl9pPr marL="8553298" indent="0" algn="ctr" defTabSz="2138324" rtl="0" eaLnBrk="1" latinLnBrk="0" hangingPunct="1">
+              <a:lnSpc>
+                <a:spcPct val="90000"/>
+              </a:lnSpc>
+              <a:spcBef>
+                <a:spcPts val="1169"/>
+              </a:spcBef>
+              <a:buFont typeface="Arial" panose="020B0604020202020204" pitchFamily="34" charset="0"/>
+              <a:buNone/>
+              <a:defRPr sz="3742" kern="1200">
+                <a:solidFill>
+                  <a:schemeClr val="tx1"/>
+                </a:solidFill>
+                <a:latin typeface="+mn-lt"/>
+                <a:ea typeface="+mn-ea"/>
+                <a:cs typeface="+mn-cs"/>
+              </a:defRPr>
+            </a:lvl9pPr>
+          </a:lstStyle>
+          <a:p>
+            <a:pPr algn="just" defTabSz="895518">
+              <a:spcBef>
+                <a:spcPct val="50000"/>
+              </a:spcBef>
+            </a:pPr>
+            <a:r>
+              <a:rPr lang="en-GB" sz="2000" b="0" i="0" noProof="1">
+                <a:solidFill>
+                  <a:srgbClr val="000000"/>
+                </a:solidFill>
+                <a:effectLst/>
+              </a:rPr>
+              <a:t>Hiermit versichere ich an Eides statt, dass ich die vorliegende Arbeit selbstständig verfasst und keine anderen als die angegebenen Quellen und Hilfsmittel benutzt habe. Alle Stellen der Arbeit, die wörtlich oder sinngemäß aus Veröffentlichungen oder aus anderweitigen fremden Äußerungen entnommen wurden, sind als solche kenntlich gemacht. Die Arbeit, in gleicher oder ähnlicher Fassung, war noch nicht Bestandteil einer Studien- oder Prüfungsleistung.</a:t>
+            </a:r>
+          </a:p>
+          <a:p>
+            <a:pPr algn="just" defTabSz="895518">
+              <a:spcBef>
+                <a:spcPct val="50000"/>
+              </a:spcBef>
+            </a:pPr>
+            <a:endParaRPr lang="en-GB" sz="2000" noProof="1">
+              <a:solidFill>
+                <a:srgbClr val="000000"/>
+              </a:solidFill>
+            </a:endParaRPr>
+          </a:p>
+          <a:p>
+            <a:pPr algn="r" defTabSz="895518">
+              <a:spcBef>
+                <a:spcPct val="50000"/>
+              </a:spcBef>
+            </a:pPr>
+            <a:r>
+              <a:rPr lang="en-GB" sz="2000" b="0" i="0" noProof="1">
+                <a:solidFill>
+                  <a:srgbClr val="000000"/>
+                </a:solidFill>
+                <a:effectLst/>
+              </a:rPr>
+              <a:t>___________________</a:t>
+            </a:r>
+          </a:p>
+          <a:p>
+            <a:pPr algn="r" defTabSz="895518">
+              <a:spcBef>
+                <a:spcPct val="50000"/>
+              </a:spcBef>
+            </a:pPr>
+            <a:r>
+              <a:rPr lang="en-GB" sz="2000" noProof="1">
+                <a:solidFill>
+                  <a:srgbClr val="000000"/>
+                </a:solidFill>
+              </a:rPr>
+              <a:t>Vorname Nachname</a:t>
+            </a:r>
+            <a:endParaRPr lang="en-GB" sz="2000" b="0" i="0" noProof="1">
+              <a:solidFill>
+                <a:srgbClr val="000000"/>
+              </a:solidFill>
+              <a:effectLst/>
+            </a:endParaRPr>
+          </a:p>
+        </p:txBody>
+      </p:sp>
+      <p:sp>
+        <p:nvSpPr>
+          <p:cNvPr id="22" name="Text Placeholder 2">
+            <a:extLst>
+              <a:ext uri="{FF2B5EF4-FFF2-40B4-BE49-F238E27FC236}">
+                <a16:creationId xmlns:a16="http://schemas.microsoft.com/office/drawing/2014/main" id="{6FD1645B-FBE7-DE47-14B3-31847E1FC498}"/>
+              </a:ext>
+            </a:extLst>
+          </p:cNvPr>
+          <p:cNvSpPr txBox="1">
+            <a:spLocks noChangeAspect="1"/>
+          </p:cNvSpPr>
+          <p:nvPr/>
+        </p:nvSpPr>
+        <p:spPr>
+          <a:xfrm>
+            <a:off x="11041655" y="21305511"/>
+            <a:ext cx="9001261" cy="927666"/>
+          </a:xfrm>
+          <a:prstGeom prst="rect">
+            <a:avLst/>
+          </a:prstGeom>
+          <a:solidFill>
+            <a:srgbClr val="00509B"/>
+          </a:solidFill>
+        </p:spPr>
+        <p:txBody>
+          <a:bodyPr vert="horz" lIns="360000" tIns="46800" rIns="108000" bIns="45720" numCol="1" rtlCol="0" anchor="ctr">
+            <a:normAutofit/>
+          </a:bodyPr>
+          <a:lstStyle>
+            <a:lvl1pPr marL="0" indent="0" algn="ctr" defTabSz="2138324" rtl="0" eaLnBrk="1" latinLnBrk="0" hangingPunct="1">
+              <a:lnSpc>
+                <a:spcPct val="90000"/>
+              </a:lnSpc>
+              <a:spcBef>
+                <a:spcPts val="2339"/>
+              </a:spcBef>
+              <a:buFont typeface="Arial" panose="020B0604020202020204" pitchFamily="34" charset="0"/>
+              <a:buNone/>
+              <a:defRPr sz="5612" kern="1200">
+                <a:solidFill>
+                  <a:schemeClr val="tx1"/>
+                </a:solidFill>
+                <a:latin typeface="Arial" panose="020B0604020202020204" pitchFamily="34" charset="0"/>
+                <a:ea typeface="+mn-ea"/>
+                <a:cs typeface="Arial" panose="020B0604020202020204" pitchFamily="34" charset="0"/>
+              </a:defRPr>
+            </a:lvl1pPr>
+            <a:lvl2pPr marL="1069162" indent="0" algn="ctr" defTabSz="2138324" rtl="0" eaLnBrk="1" latinLnBrk="0" hangingPunct="1">
+              <a:lnSpc>
+                <a:spcPct val="90000"/>
+              </a:lnSpc>
+              <a:spcBef>
+                <a:spcPts val="1169"/>
+              </a:spcBef>
+              <a:buFont typeface="Arial" panose="020B0604020202020204" pitchFamily="34" charset="0"/>
+              <a:buNone/>
+              <a:defRPr sz="4677" kern="1200">
+                <a:solidFill>
+                  <a:schemeClr val="tx1"/>
+                </a:solidFill>
+                <a:latin typeface="Arial" panose="020B0604020202020204" pitchFamily="34" charset="0"/>
+                <a:ea typeface="+mn-ea"/>
+                <a:cs typeface="Arial" panose="020B0604020202020204" pitchFamily="34" charset="0"/>
+              </a:defRPr>
+            </a:lvl2pPr>
+            <a:lvl3pPr marL="2138324" indent="0" algn="ctr" defTabSz="2138324" rtl="0" eaLnBrk="1" latinLnBrk="0" hangingPunct="1">
+              <a:lnSpc>
+                <a:spcPct val="90000"/>
+              </a:lnSpc>
+              <a:spcBef>
+                <a:spcPts val="1169"/>
+              </a:spcBef>
+              <a:buFont typeface="Arial" panose="020B0604020202020204" pitchFamily="34" charset="0"/>
+              <a:buNone/>
+              <a:defRPr sz="4209" kern="1200">
+                <a:solidFill>
+                  <a:schemeClr val="tx1"/>
+                </a:solidFill>
+                <a:latin typeface="Arial" panose="020B0604020202020204" pitchFamily="34" charset="0"/>
+                <a:ea typeface="+mn-ea"/>
+                <a:cs typeface="Arial" panose="020B0604020202020204" pitchFamily="34" charset="0"/>
+              </a:defRPr>
+            </a:lvl3pPr>
+            <a:lvl4pPr marL="3207487" indent="0" algn="ctr" defTabSz="2138324" rtl="0" eaLnBrk="1" latinLnBrk="0" hangingPunct="1">
+              <a:lnSpc>
+                <a:spcPct val="90000"/>
+              </a:lnSpc>
+              <a:spcBef>
+                <a:spcPts val="1169"/>
+              </a:spcBef>
+              <a:buFont typeface="Arial" panose="020B0604020202020204" pitchFamily="34" charset="0"/>
+              <a:buNone/>
+              <a:defRPr sz="3742" kern="1200">
+                <a:solidFill>
+                  <a:schemeClr val="tx1"/>
+                </a:solidFill>
+                <a:latin typeface="Arial" panose="020B0604020202020204" pitchFamily="34" charset="0"/>
+                <a:ea typeface="+mn-ea"/>
+                <a:cs typeface="Arial" panose="020B0604020202020204" pitchFamily="34" charset="0"/>
+              </a:defRPr>
+            </a:lvl4pPr>
+            <a:lvl5pPr marL="4276649" indent="0" algn="ctr" defTabSz="2138324" rtl="0" eaLnBrk="1" latinLnBrk="0" hangingPunct="1">
+              <a:lnSpc>
+                <a:spcPct val="90000"/>
+              </a:lnSpc>
+              <a:spcBef>
+                <a:spcPts val="1169"/>
+              </a:spcBef>
+              <a:buFont typeface="Arial" panose="020B0604020202020204" pitchFamily="34" charset="0"/>
+              <a:buNone/>
+              <a:defRPr sz="3742" kern="1200">
+                <a:solidFill>
+                  <a:schemeClr val="tx1"/>
+                </a:solidFill>
+                <a:latin typeface="Arial" panose="020B0604020202020204" pitchFamily="34" charset="0"/>
+                <a:ea typeface="+mn-ea"/>
+                <a:cs typeface="Arial" panose="020B0604020202020204" pitchFamily="34" charset="0"/>
+              </a:defRPr>
+            </a:lvl5pPr>
+            <a:lvl6pPr marL="5345811" indent="0" algn="ctr" defTabSz="2138324" rtl="0" eaLnBrk="1" latinLnBrk="0" hangingPunct="1">
+              <a:lnSpc>
+                <a:spcPct val="90000"/>
+              </a:lnSpc>
+              <a:spcBef>
+                <a:spcPts val="1169"/>
+              </a:spcBef>
+              <a:buFont typeface="Arial" panose="020B0604020202020204" pitchFamily="34" charset="0"/>
+              <a:buNone/>
+              <a:defRPr sz="3742" kern="1200">
+                <a:solidFill>
+                  <a:schemeClr val="tx1"/>
+                </a:solidFill>
+                <a:latin typeface="+mn-lt"/>
+                <a:ea typeface="+mn-ea"/>
+                <a:cs typeface="+mn-cs"/>
+              </a:defRPr>
+            </a:lvl6pPr>
+            <a:lvl7pPr marL="6414973" indent="0" algn="ctr" defTabSz="2138324" rtl="0" eaLnBrk="1" latinLnBrk="0" hangingPunct="1">
+              <a:lnSpc>
+                <a:spcPct val="90000"/>
+              </a:lnSpc>
+              <a:spcBef>
+                <a:spcPts val="1169"/>
+              </a:spcBef>
+              <a:buFont typeface="Arial" panose="020B0604020202020204" pitchFamily="34" charset="0"/>
+              <a:buNone/>
+              <a:defRPr sz="3742" kern="1200">
+                <a:solidFill>
+                  <a:schemeClr val="tx1"/>
+                </a:solidFill>
+                <a:latin typeface="+mn-lt"/>
+                <a:ea typeface="+mn-ea"/>
+                <a:cs typeface="+mn-cs"/>
+              </a:defRPr>
+            </a:lvl7pPr>
+            <a:lvl8pPr marL="7484135" indent="0" algn="ctr" defTabSz="2138324" rtl="0" eaLnBrk="1" latinLnBrk="0" hangingPunct="1">
+              <a:lnSpc>
+                <a:spcPct val="90000"/>
+              </a:lnSpc>
+              <a:spcBef>
+                <a:spcPts val="1169"/>
+              </a:spcBef>
+              <a:buFont typeface="Arial" panose="020B0604020202020204" pitchFamily="34" charset="0"/>
+              <a:buNone/>
+              <a:defRPr sz="3742" kern="1200">
+                <a:solidFill>
+                  <a:schemeClr val="tx1"/>
+                </a:solidFill>
+                <a:latin typeface="+mn-lt"/>
+                <a:ea typeface="+mn-ea"/>
+                <a:cs typeface="+mn-cs"/>
+              </a:defRPr>
+            </a:lvl8pPr>
+            <a:lvl9pPr marL="8553298" indent="0" algn="ctr" defTabSz="2138324" rtl="0" eaLnBrk="1" latinLnBrk="0" hangingPunct="1">
+              <a:lnSpc>
+                <a:spcPct val="90000"/>
+              </a:lnSpc>
+              <a:spcBef>
+                <a:spcPts val="1169"/>
+              </a:spcBef>
+              <a:buFont typeface="Arial" panose="020B0604020202020204" pitchFamily="34" charset="0"/>
+              <a:buNone/>
+              <a:defRPr sz="3742" kern="1200">
+                <a:solidFill>
+                  <a:schemeClr val="tx1"/>
+                </a:solidFill>
+                <a:latin typeface="+mn-lt"/>
+                <a:ea typeface="+mn-ea"/>
+                <a:cs typeface="+mn-cs"/>
+              </a:defRPr>
+            </a:lvl9pPr>
+          </a:lstStyle>
+          <a:p>
+            <a:pPr algn="l"/>
+            <a:r>
+              <a:rPr lang="de-DE" sz="3200" b="1" noProof="1">
+                <a:solidFill>
+                  <a:schemeClr val="bg1"/>
+                </a:solidFill>
+              </a:rPr>
+              <a:t>Erklärung zur Nutzung von KI Werkzeugen</a:t>
+            </a:r>
+          </a:p>
+        </p:txBody>
+      </p:sp>
+      <p:sp>
+        <p:nvSpPr>
+          <p:cNvPr id="24" name="Text Placeholder 2">
+            <a:extLst>
+              <a:ext uri="{FF2B5EF4-FFF2-40B4-BE49-F238E27FC236}">
+                <a16:creationId xmlns:a16="http://schemas.microsoft.com/office/drawing/2014/main" id="{D7D0E442-AA0F-FDE3-19A9-23F0963F06A6}"/>
+              </a:ext>
+            </a:extLst>
+          </p:cNvPr>
+          <p:cNvSpPr txBox="1">
+            <a:spLocks/>
+          </p:cNvSpPr>
+          <p:nvPr/>
+        </p:nvSpPr>
+        <p:spPr>
+          <a:xfrm>
+            <a:off x="11041655" y="22424418"/>
+            <a:ext cx="9001260" cy="6034668"/>
+          </a:xfrm>
+          <a:prstGeom prst="rect">
+            <a:avLst/>
+          </a:prstGeom>
+          <a:solidFill>
+            <a:schemeClr val="bg1">
+              <a:lumMod val="95000"/>
+            </a:schemeClr>
+          </a:solidFill>
+        </p:spPr>
+        <p:txBody>
+          <a:bodyPr vert="horz" lIns="360000" tIns="360000" rIns="360000" bIns="360000" numCol="1" rtlCol="0">
+            <a:noAutofit/>
+          </a:bodyPr>
+          <a:lstStyle>
+            <a:lvl1pPr marL="0" indent="0" algn="ctr" defTabSz="2138324" rtl="0" eaLnBrk="1" latinLnBrk="0" hangingPunct="1">
+              <a:lnSpc>
+                <a:spcPct val="90000"/>
+              </a:lnSpc>
+              <a:spcBef>
+                <a:spcPts val="2339"/>
+              </a:spcBef>
+              <a:buFont typeface="Arial" panose="020B0604020202020204" pitchFamily="34" charset="0"/>
+              <a:buNone/>
+              <a:defRPr sz="5612" kern="1200">
+                <a:solidFill>
+                  <a:schemeClr val="tx1"/>
+                </a:solidFill>
+                <a:latin typeface="Arial" panose="020B0604020202020204" pitchFamily="34" charset="0"/>
+                <a:ea typeface="+mn-ea"/>
+                <a:cs typeface="Arial" panose="020B0604020202020204" pitchFamily="34" charset="0"/>
+              </a:defRPr>
+            </a:lvl1pPr>
+            <a:lvl2pPr marL="1069162" indent="0" algn="ctr" defTabSz="2138324" rtl="0" eaLnBrk="1" latinLnBrk="0" hangingPunct="1">
+              <a:lnSpc>
+                <a:spcPct val="90000"/>
+              </a:lnSpc>
+              <a:spcBef>
+                <a:spcPts val="1169"/>
+              </a:spcBef>
+              <a:buFont typeface="Arial" panose="020B0604020202020204" pitchFamily="34" charset="0"/>
+              <a:buNone/>
+              <a:defRPr sz="4677" kern="1200">
+                <a:solidFill>
+                  <a:schemeClr val="tx1"/>
+                </a:solidFill>
+                <a:latin typeface="Arial" panose="020B0604020202020204" pitchFamily="34" charset="0"/>
+                <a:ea typeface="+mn-ea"/>
+                <a:cs typeface="Arial" panose="020B0604020202020204" pitchFamily="34" charset="0"/>
+              </a:defRPr>
+            </a:lvl2pPr>
+            <a:lvl3pPr marL="2138324" indent="0" algn="ctr" defTabSz="2138324" rtl="0" eaLnBrk="1" latinLnBrk="0" hangingPunct="1">
+              <a:lnSpc>
+                <a:spcPct val="90000"/>
+              </a:lnSpc>
+              <a:spcBef>
+                <a:spcPts val="1169"/>
+              </a:spcBef>
+              <a:buFont typeface="Arial" panose="020B0604020202020204" pitchFamily="34" charset="0"/>
+              <a:buNone/>
+              <a:defRPr sz="4209" kern="1200">
+                <a:solidFill>
+                  <a:schemeClr val="tx1"/>
+                </a:solidFill>
+                <a:latin typeface="Arial" panose="020B0604020202020204" pitchFamily="34" charset="0"/>
+                <a:ea typeface="+mn-ea"/>
+                <a:cs typeface="Arial" panose="020B0604020202020204" pitchFamily="34" charset="0"/>
+              </a:defRPr>
+            </a:lvl3pPr>
+            <a:lvl4pPr marL="3207487" indent="0" algn="ctr" defTabSz="2138324" rtl="0" eaLnBrk="1" latinLnBrk="0" hangingPunct="1">
+              <a:lnSpc>
+                <a:spcPct val="90000"/>
+              </a:lnSpc>
+              <a:spcBef>
+                <a:spcPts val="1169"/>
+              </a:spcBef>
+              <a:buFont typeface="Arial" panose="020B0604020202020204" pitchFamily="34" charset="0"/>
+              <a:buNone/>
+              <a:defRPr sz="3742" kern="1200">
+                <a:solidFill>
+                  <a:schemeClr val="tx1"/>
+                </a:solidFill>
+                <a:latin typeface="Arial" panose="020B0604020202020204" pitchFamily="34" charset="0"/>
+                <a:ea typeface="+mn-ea"/>
+                <a:cs typeface="Arial" panose="020B0604020202020204" pitchFamily="34" charset="0"/>
+              </a:defRPr>
+            </a:lvl4pPr>
+            <a:lvl5pPr marL="4276649" indent="0" algn="ctr" defTabSz="2138324" rtl="0" eaLnBrk="1" latinLnBrk="0" hangingPunct="1">
+              <a:lnSpc>
+                <a:spcPct val="90000"/>
+              </a:lnSpc>
+              <a:spcBef>
+                <a:spcPts val="1169"/>
+              </a:spcBef>
+              <a:buFont typeface="Arial" panose="020B0604020202020204" pitchFamily="34" charset="0"/>
+              <a:buNone/>
+              <a:defRPr sz="3742" kern="1200">
+                <a:solidFill>
+                  <a:schemeClr val="tx1"/>
+                </a:solidFill>
+                <a:latin typeface="Arial" panose="020B0604020202020204" pitchFamily="34" charset="0"/>
+                <a:ea typeface="+mn-ea"/>
+                <a:cs typeface="Arial" panose="020B0604020202020204" pitchFamily="34" charset="0"/>
+              </a:defRPr>
+            </a:lvl5pPr>
+            <a:lvl6pPr marL="5345811" indent="0" algn="ctr" defTabSz="2138324" rtl="0" eaLnBrk="1" latinLnBrk="0" hangingPunct="1">
+              <a:lnSpc>
+                <a:spcPct val="90000"/>
+              </a:lnSpc>
+              <a:spcBef>
+                <a:spcPts val="1169"/>
+              </a:spcBef>
+              <a:buFont typeface="Arial" panose="020B0604020202020204" pitchFamily="34" charset="0"/>
+              <a:buNone/>
+              <a:defRPr sz="3742" kern="1200">
+                <a:solidFill>
+                  <a:schemeClr val="tx1"/>
+                </a:solidFill>
+                <a:latin typeface="+mn-lt"/>
+                <a:ea typeface="+mn-ea"/>
+                <a:cs typeface="+mn-cs"/>
+              </a:defRPr>
+            </a:lvl6pPr>
+            <a:lvl7pPr marL="6414973" indent="0" algn="ctr" defTabSz="2138324" rtl="0" eaLnBrk="1" latinLnBrk="0" hangingPunct="1">
+              <a:lnSpc>
+                <a:spcPct val="90000"/>
+              </a:lnSpc>
+              <a:spcBef>
+                <a:spcPts val="1169"/>
+              </a:spcBef>
+              <a:buFont typeface="Arial" panose="020B0604020202020204" pitchFamily="34" charset="0"/>
+              <a:buNone/>
+              <a:defRPr sz="3742" kern="1200">
+                <a:solidFill>
+                  <a:schemeClr val="tx1"/>
+                </a:solidFill>
+                <a:latin typeface="+mn-lt"/>
+                <a:ea typeface="+mn-ea"/>
+                <a:cs typeface="+mn-cs"/>
+              </a:defRPr>
+            </a:lvl7pPr>
+            <a:lvl8pPr marL="7484135" indent="0" algn="ctr" defTabSz="2138324" rtl="0" eaLnBrk="1" latinLnBrk="0" hangingPunct="1">
+              <a:lnSpc>
+                <a:spcPct val="90000"/>
+              </a:lnSpc>
+              <a:spcBef>
+                <a:spcPts val="1169"/>
+              </a:spcBef>
+              <a:buFont typeface="Arial" panose="020B0604020202020204" pitchFamily="34" charset="0"/>
+              <a:buNone/>
+              <a:defRPr sz="3742" kern="1200">
+                <a:solidFill>
+                  <a:schemeClr val="tx1"/>
+                </a:solidFill>
+                <a:latin typeface="+mn-lt"/>
+                <a:ea typeface="+mn-ea"/>
+                <a:cs typeface="+mn-cs"/>
+              </a:defRPr>
+            </a:lvl8pPr>
+            <a:lvl9pPr marL="8553298" indent="0" algn="ctr" defTabSz="2138324" rtl="0" eaLnBrk="1" latinLnBrk="0" hangingPunct="1">
+              <a:lnSpc>
+                <a:spcPct val="90000"/>
+              </a:lnSpc>
+              <a:spcBef>
+                <a:spcPts val="1169"/>
+              </a:spcBef>
+              <a:buFont typeface="Arial" panose="020B0604020202020204" pitchFamily="34" charset="0"/>
+              <a:buNone/>
+              <a:defRPr sz="3742" kern="1200">
+                <a:solidFill>
+                  <a:schemeClr val="tx1"/>
+                </a:solidFill>
+                <a:latin typeface="+mn-lt"/>
+                <a:ea typeface="+mn-ea"/>
+                <a:cs typeface="+mn-cs"/>
+              </a:defRPr>
+            </a:lvl9pPr>
+          </a:lstStyle>
+          <a:p>
+            <a:pPr algn="just" defTabSz="895518">
+              <a:spcBef>
+                <a:spcPct val="50000"/>
+              </a:spcBef>
+            </a:pPr>
+            <a:r>
+              <a:rPr lang="en-GB" sz="2000" b="0" i="0" noProof="1">
+                <a:solidFill>
+                  <a:srgbClr val="000000"/>
+                </a:solidFill>
+                <a:effectLst/>
+              </a:rPr>
+              <a:t>Hiermit versichere ich an Eides statt, dass ich die vorliegende Arbeit selbstständig verfasst und keine anderen als die angegebenen Quellen und Hilfsmittel benutzt habe. Alle Stellen der Arbeit, die wörtlich oder sinngemäß aus Veröffentlichungen oder aus anderweitigen fremden Äußerungen entnommen wurden, sind als solche kenntlich gemacht. Die Arbeit, in gleicher oder ähnlicher Fassung, war noch nicht Bestandteil einer Studien- oder Prüfungsleistung.</a:t>
+            </a:r>
+          </a:p>
+        </p:txBody>
+      </p:sp>
+    </p:spTree>
+    <p:extLst>
+      <p:ext uri="{BB962C8B-B14F-4D97-AF65-F5344CB8AC3E}">
+        <p14:creationId xmlns:p14="http://schemas.microsoft.com/office/powerpoint/2010/main" val="305240870"/>
+      </p:ext>
+    </p:extLst>
+  </p:cSld>
+  <p:clrMapOvr>
+    <a:masterClrMapping/>
+  </p:clrMapOvr>
+</p:sld>
+</file>
+
+<file path=ppt/slides/slide3.xml><?xml version="1.0" encoding="utf-8"?>
 <p:sld xmlns:a="http://schemas.openxmlformats.org/drawingml/2006/main" xmlns:r="http://schemas.openxmlformats.org/officeDocument/2006/relationships" xmlns:p="http://schemas.openxmlformats.org/presentationml/2006/main">
   <p:cSld>
     <p:spTree>
@@ -15805,8 +18030,8 @@
           </a:p>
         </p:txBody>
       </p:sp>
-      <mc:AlternateContent xmlns:mc="http://schemas.openxmlformats.org/markup-compatibility/2006">
-        <mc:Choice xmlns:a14="http://schemas.microsoft.com/office/drawing/2010/main" Requires="a14">
+      <mc:AlternateContent xmlns:mc="http://schemas.openxmlformats.org/markup-compatibility/2006" xmlns:a14="http://schemas.microsoft.com/office/drawing/2010/main">
+        <mc:Choice Requires="a14">
           <p:sp>
             <p:nvSpPr>
               <p:cNvPr id="7" name="Text Placeholder 2">
@@ -17608,7 +19833,7 @@
             </p:txBody>
           </p:sp>
         </mc:Choice>
-        <mc:Fallback>
+        <mc:Fallback xmlns="">
           <p:sp>
             <p:nvSpPr>
               <p:cNvPr id="7" name="Text Placeholder 2">
@@ -20805,10 +23030,10 @@
           <p:nvPr/>
         </p:nvPicPr>
         <p:blipFill rotWithShape="1">
-          <a:blip r:embed="rId4">
+          <a:blip>
             <a:extLst>
               <a:ext uri="{96DAC541-7B7A-43D3-8B79-37D633B846F1}">
-                <asvg:svgBlip xmlns:asvg="http://schemas.microsoft.com/office/drawing/2016/SVG/main" r:embed="rId5"/>
+                <asvg:svgBlip xmlns:asvg="http://schemas.microsoft.com/office/drawing/2016/SVG/main" r:embed="rId4"/>
               </a:ext>
             </a:extLst>
           </a:blip>
@@ -25249,7 +27474,7 @@
           <p:nvPr/>
         </p:nvPicPr>
         <p:blipFill>
-          <a:blip r:embed="rId6">
+          <a:blip r:embed="rId5">
             <a:extLst>
               <a:ext uri="{28A0092B-C50C-407E-A947-70E740481C1C}">
                 <a14:useLocalDpi xmlns:a14="http://schemas.microsoft.com/office/drawing/2010/main" val="0"/>
@@ -27738,16 +29963,288 @@
                 <a:ea typeface="Helvetica Neue Medium" panose="02000503000000020004" pitchFamily="2" charset="0"/>
                 <a:cs typeface="Helvetica Neue Medium" panose="02000503000000020004" pitchFamily="2" charset="0"/>
               </a:rPr>
-              <a:t>Front A2 (420mm x 592mm)</a:t>
-            </a:r>
-            <a:endParaRPr lang="de-DE" sz="10000" dirty="0">
-              <a:latin typeface="Helvetica Neue Medium" panose="02000503000000020004" pitchFamily="2" charset="0"/>
-              <a:ea typeface="Helvetica Neue Medium" panose="02000503000000020004" pitchFamily="2" charset="0"/>
-              <a:cs typeface="Helvetica Neue Medium" panose="02000503000000020004" pitchFamily="2" charset="0"/>
-            </a:endParaRPr>
+              <a:t>Front A1 (594mm x 841mm)</a:t>
+            </a:r>
           </a:p>
         </p:txBody>
       </p:sp>
+      <p:grpSp>
+        <p:nvGrpSpPr>
+          <p:cNvPr id="30" name="Gruppieren 29">
+            <a:extLst>
+              <a:ext uri="{FF2B5EF4-FFF2-40B4-BE49-F238E27FC236}">
+                <a16:creationId xmlns:a16="http://schemas.microsoft.com/office/drawing/2014/main" id="{AF1AD814-E378-BE69-587A-964EC132F5C9}"/>
+              </a:ext>
+            </a:extLst>
+          </p:cNvPr>
+          <p:cNvGrpSpPr/>
+          <p:nvPr/>
+        </p:nvGrpSpPr>
+        <p:grpSpPr>
+          <a:xfrm>
+            <a:off x="22963250" y="-1575609"/>
+            <a:ext cx="8580093" cy="16044118"/>
+            <a:chOff x="23914791" y="-1323439"/>
+            <a:chExt cx="8580093" cy="16044118"/>
+          </a:xfrm>
+        </p:grpSpPr>
+        <p:sp>
+          <p:nvSpPr>
+            <p:cNvPr id="31" name="Rechteck 30">
+              <a:extLst>
+                <a:ext uri="{FF2B5EF4-FFF2-40B4-BE49-F238E27FC236}">
+                  <a16:creationId xmlns:a16="http://schemas.microsoft.com/office/drawing/2014/main" id="{A68580D1-3482-8B96-ABA0-334A996D5D90}"/>
+                </a:ext>
+              </a:extLst>
+            </p:cNvPr>
+            <p:cNvSpPr/>
+            <p:nvPr/>
+          </p:nvSpPr>
+          <p:spPr>
+            <a:xfrm>
+              <a:off x="23941284" y="6050531"/>
+              <a:ext cx="8553600" cy="6048000"/>
+            </a:xfrm>
+            <a:prstGeom prst="rect">
+              <a:avLst/>
+            </a:prstGeom>
+            <a:solidFill>
+              <a:srgbClr val="00509B"/>
+            </a:solidFill>
+            <a:ln w="63500"/>
+          </p:spPr>
+          <p:style>
+            <a:lnRef idx="2">
+              <a:schemeClr val="accent1">
+                <a:shade val="15000"/>
+              </a:schemeClr>
+            </a:lnRef>
+            <a:fillRef idx="1">
+              <a:schemeClr val="accent1"/>
+            </a:fillRef>
+            <a:effectRef idx="0">
+              <a:schemeClr val="accent1"/>
+            </a:effectRef>
+            <a:fontRef idx="minor">
+              <a:schemeClr val="lt1"/>
+            </a:fontRef>
+          </p:style>
+          <p:txBody>
+            <a:bodyPr rtlCol="0" anchor="ctr"/>
+            <a:lstStyle/>
+            <a:p>
+              <a:pPr algn="ctr"/>
+              <a:r>
+                <a:rPr lang="de-DE" sz="8000" b="1" dirty="0">
+                  <a:latin typeface="Arial" panose="020B0604020202020204" pitchFamily="34" charset="0"/>
+                  <a:cs typeface="Arial" panose="020B0604020202020204" pitchFamily="34" charset="0"/>
+                </a:rPr>
+                <a:t>A2</a:t>
+              </a:r>
+            </a:p>
+          </p:txBody>
+        </p:sp>
+        <p:sp>
+          <p:nvSpPr>
+            <p:cNvPr id="37" name="Rechteck 36">
+              <a:extLst>
+                <a:ext uri="{FF2B5EF4-FFF2-40B4-BE49-F238E27FC236}">
+                  <a16:creationId xmlns:a16="http://schemas.microsoft.com/office/drawing/2014/main" id="{689DC8BB-D460-B3ED-1F6A-3C7DFE9602EE}"/>
+                </a:ext>
+              </a:extLst>
+            </p:cNvPr>
+            <p:cNvSpPr/>
+            <p:nvPr/>
+          </p:nvSpPr>
+          <p:spPr>
+            <a:xfrm>
+              <a:off x="28218084" y="0"/>
+              <a:ext cx="4276800" cy="6048000"/>
+            </a:xfrm>
+            <a:prstGeom prst="rect">
+              <a:avLst/>
+            </a:prstGeom>
+            <a:solidFill>
+              <a:srgbClr val="00509B"/>
+            </a:solidFill>
+            <a:ln w="63500"/>
+          </p:spPr>
+          <p:style>
+            <a:lnRef idx="2">
+              <a:schemeClr val="accent1">
+                <a:shade val="15000"/>
+              </a:schemeClr>
+            </a:lnRef>
+            <a:fillRef idx="1">
+              <a:schemeClr val="accent1"/>
+            </a:fillRef>
+            <a:effectRef idx="0">
+              <a:schemeClr val="accent1"/>
+            </a:effectRef>
+            <a:fontRef idx="minor">
+              <a:schemeClr val="lt1"/>
+            </a:fontRef>
+          </p:style>
+          <p:txBody>
+            <a:bodyPr rtlCol="0" anchor="ctr"/>
+            <a:lstStyle/>
+            <a:p>
+              <a:pPr algn="ctr"/>
+              <a:r>
+                <a:rPr lang="de-DE" sz="8000" b="1" dirty="0">
+                  <a:latin typeface="Arial" panose="020B0604020202020204" pitchFamily="34" charset="0"/>
+                  <a:cs typeface="Arial" panose="020B0604020202020204" pitchFamily="34" charset="0"/>
+                </a:rPr>
+                <a:t>A3</a:t>
+              </a:r>
+            </a:p>
+          </p:txBody>
+        </p:sp>
+        <p:sp>
+          <p:nvSpPr>
+            <p:cNvPr id="38" name="Rechteck 37">
+              <a:extLst>
+                <a:ext uri="{FF2B5EF4-FFF2-40B4-BE49-F238E27FC236}">
+                  <a16:creationId xmlns:a16="http://schemas.microsoft.com/office/drawing/2014/main" id="{D9509C4A-C2A4-7DE7-76F5-66050B9A2B18}"/>
+                </a:ext>
+              </a:extLst>
+            </p:cNvPr>
+            <p:cNvSpPr/>
+            <p:nvPr/>
+          </p:nvSpPr>
+          <p:spPr>
+            <a:xfrm>
+              <a:off x="23941284" y="0"/>
+              <a:ext cx="4276800" cy="6048000"/>
+            </a:xfrm>
+            <a:prstGeom prst="rect">
+              <a:avLst/>
+            </a:prstGeom>
+            <a:solidFill>
+              <a:srgbClr val="00509B"/>
+            </a:solidFill>
+            <a:ln w="63500"/>
+          </p:spPr>
+          <p:style>
+            <a:lnRef idx="2">
+              <a:schemeClr val="accent1">
+                <a:shade val="15000"/>
+              </a:schemeClr>
+            </a:lnRef>
+            <a:fillRef idx="1">
+              <a:schemeClr val="accent1"/>
+            </a:fillRef>
+            <a:effectRef idx="0">
+              <a:schemeClr val="accent1"/>
+            </a:effectRef>
+            <a:fontRef idx="minor">
+              <a:schemeClr val="lt1"/>
+            </a:fontRef>
+          </p:style>
+          <p:txBody>
+            <a:bodyPr rtlCol="0" anchor="ctr"/>
+            <a:lstStyle/>
+            <a:p>
+              <a:pPr algn="ctr"/>
+              <a:r>
+                <a:rPr lang="de-DE" sz="8000" b="1" dirty="0">
+                  <a:latin typeface="Arial" panose="020B0604020202020204" pitchFamily="34" charset="0"/>
+                  <a:cs typeface="Arial" panose="020B0604020202020204" pitchFamily="34" charset="0"/>
+                </a:rPr>
+                <a:t>A3</a:t>
+              </a:r>
+            </a:p>
+          </p:txBody>
+        </p:sp>
+        <p:sp>
+          <p:nvSpPr>
+            <p:cNvPr id="46" name="Textfeld 45">
+              <a:extLst>
+                <a:ext uri="{FF2B5EF4-FFF2-40B4-BE49-F238E27FC236}">
+                  <a16:creationId xmlns:a16="http://schemas.microsoft.com/office/drawing/2014/main" id="{E0ED8F98-34A0-25FC-DB80-2AF2B014ED79}"/>
+                </a:ext>
+              </a:extLst>
+            </p:cNvPr>
+            <p:cNvSpPr txBox="1"/>
+            <p:nvPr/>
+          </p:nvSpPr>
+          <p:spPr>
+            <a:xfrm>
+              <a:off x="23914792" y="-1323439"/>
+              <a:ext cx="6234399" cy="1323439"/>
+            </a:xfrm>
+            <a:prstGeom prst="rect">
+              <a:avLst/>
+            </a:prstGeom>
+            <a:noFill/>
+          </p:spPr>
+          <p:txBody>
+            <a:bodyPr wrap="none" rtlCol="0">
+              <a:spAutoFit/>
+            </a:bodyPr>
+            <a:lstStyle/>
+            <a:p>
+              <a:r>
+                <a:rPr lang="de-DE" sz="8000" b="1" dirty="0">
+                  <a:latin typeface="Arial" panose="020B0604020202020204" pitchFamily="34" charset="0"/>
+                  <a:cs typeface="Arial" panose="020B0604020202020204" pitchFamily="34" charset="0"/>
+                </a:rPr>
+                <a:t>A1 </a:t>
+              </a:r>
+              <a:r>
+                <a:rPr lang="de-DE" sz="4000" b="1" dirty="0">
+                  <a:latin typeface="Arial" panose="020B0604020202020204" pitchFamily="34" charset="0"/>
+                  <a:cs typeface="Arial" panose="020B0604020202020204" pitchFamily="34" charset="0"/>
+                </a:rPr>
+                <a:t>(594mm x 841mm)</a:t>
+              </a:r>
+            </a:p>
+          </p:txBody>
+        </p:sp>
+        <p:sp>
+          <p:nvSpPr>
+            <p:cNvPr id="47" name="Textfeld 46">
+              <a:extLst>
+                <a:ext uri="{FF2B5EF4-FFF2-40B4-BE49-F238E27FC236}">
+                  <a16:creationId xmlns:a16="http://schemas.microsoft.com/office/drawing/2014/main" id="{85CCB150-53FC-F3C8-C76E-63508C06AD9F}"/>
+                </a:ext>
+              </a:extLst>
+            </p:cNvPr>
+            <p:cNvSpPr txBox="1"/>
+            <p:nvPr/>
+          </p:nvSpPr>
+          <p:spPr>
+            <a:xfrm>
+              <a:off x="23914791" y="12444344"/>
+              <a:ext cx="8553600" cy="2276335"/>
+            </a:xfrm>
+            <a:prstGeom prst="rect">
+              <a:avLst/>
+            </a:prstGeom>
+            <a:noFill/>
+          </p:spPr>
+          <p:txBody>
+            <a:bodyPr wrap="square" rtlCol="0">
+              <a:noAutofit/>
+            </a:bodyPr>
+            <a:lstStyle/>
+            <a:p>
+              <a:pPr algn="just">
+                <a:lnSpc>
+                  <a:spcPct val="90000"/>
+                </a:lnSpc>
+              </a:pPr>
+              <a:r>
+                <a:rPr lang="en-GB" sz="3600" noProof="1">
+                  <a:latin typeface="Arial" panose="020B0604020202020204" pitchFamily="34" charset="0"/>
+                  <a:cs typeface="Arial" panose="020B0604020202020204" pitchFamily="34" charset="0"/>
+                </a:rPr>
+                <a:t>This Poster is to be printed in A1, which can be achieved by combining four A3 or eight A4 sheets. The printers at Fachhochschule Südwestfalen are able to print A3 sheets.</a:t>
+              </a:r>
+            </a:p>
+          </p:txBody>
+        </p:sp>
+      </p:grpSp>
     </p:spTree>
     <p:extLst>
       <p:ext uri="{BB962C8B-B14F-4D97-AF65-F5344CB8AC3E}">
@@ -27761,7 +30258,7 @@
 </p:sld>
 </file>
 
-<file path=ppt/slides/slide3.xml><?xml version="1.0" encoding="utf-8"?>
+<file path=ppt/slides/slide4.xml><?xml version="1.0" encoding="utf-8"?>
 <p:sld xmlns:a="http://schemas.openxmlformats.org/drawingml/2006/main" xmlns:r="http://schemas.openxmlformats.org/officeDocument/2006/relationships" xmlns:p="http://schemas.openxmlformats.org/presentationml/2006/main">
   <p:cSld>
     <p:spTree>

</xml_diff>